<commit_message>
updated NASA API Rmd, and XML Scraping Rmd
</commit_message>
<xml_diff>
--- a/Unit 4 Tidyverse/Isabella_Westlauer_FLS_Unit4.pptx
+++ b/Unit 4 Tidyverse/Isabella_Westlauer_FLS_Unit4.pptx
@@ -6,12 +6,20 @@
   </p:sldMasterIdLst>
   <p:sldIdLst>
     <p:sldId id="256" r:id="rId2"/>
-    <p:sldId id="257" r:id="rId3"/>
-    <p:sldId id="258" r:id="rId4"/>
-    <p:sldId id="259" r:id="rId5"/>
-    <p:sldId id="260" r:id="rId6"/>
-    <p:sldId id="262" r:id="rId7"/>
-    <p:sldId id="261" r:id="rId8"/>
+    <p:sldId id="258" r:id="rId3"/>
+    <p:sldId id="259" r:id="rId4"/>
+    <p:sldId id="267" r:id="rId5"/>
+    <p:sldId id="268" r:id="rId6"/>
+    <p:sldId id="269" r:id="rId7"/>
+    <p:sldId id="264" r:id="rId8"/>
+    <p:sldId id="262" r:id="rId9"/>
+    <p:sldId id="260" r:id="rId10"/>
+    <p:sldId id="271" r:id="rId11"/>
+    <p:sldId id="272" r:id="rId12"/>
+    <p:sldId id="274" r:id="rId13"/>
+    <p:sldId id="265" r:id="rId14"/>
+    <p:sldId id="270" r:id="rId15"/>
+    <p:sldId id="273" r:id="rId16"/>
   </p:sldIdLst>
   <p:sldSz cx="12192000" cy="6858000"/>
   <p:notesSz cx="6858000" cy="9144000"/>
@@ -111,6 +119,37 @@
     </a:lvl9pPr>
   </p:defaultTextStyle>
   <p:extLst>
+    <p:ext uri="{521415D9-36F7-43E2-AB2F-B90AF26B5E84}">
+      <p14:sectionLst xmlns:p14="http://schemas.microsoft.com/office/powerpoint/2010/main">
+        <p14:section name="Default Section" id="{BA526555-8ECF-4B28-9D41-AED62B0959EB}">
+          <p14:sldIdLst>
+            <p14:sldId id="256"/>
+          </p14:sldIdLst>
+        </p14:section>
+        <p14:section name="web scraping xml" id="{DA69CB1B-9DE1-4824-9A46-D8EB8128038C}">
+          <p14:sldIdLst>
+            <p14:sldId id="258"/>
+            <p14:sldId id="259"/>
+            <p14:sldId id="267"/>
+            <p14:sldId id="268"/>
+            <p14:sldId id="269"/>
+          </p14:sldIdLst>
+        </p14:section>
+        <p14:section name="NASA SMALL BODY DB API" id="{A8E8E33C-9547-43EF-9642-0241D5888430}">
+          <p14:sldIdLst>
+            <p14:sldId id="264"/>
+            <p14:sldId id="262"/>
+            <p14:sldId id="260"/>
+            <p14:sldId id="271"/>
+            <p14:sldId id="272"/>
+            <p14:sldId id="274"/>
+            <p14:sldId id="265"/>
+            <p14:sldId id="270"/>
+            <p14:sldId id="273"/>
+          </p14:sldIdLst>
+        </p14:section>
+      </p14:sectionLst>
+    </p:ext>
     <p:ext uri="{EFAFB233-063F-42B5-8137-9DF3F51BA10A}">
       <p15:sldGuideLst xmlns:p15="http://schemas.microsoft.com/office/powerpoint/2012/main"/>
     </p:ext>
@@ -265,7 +304,7 @@
           <a:p>
             <a:fld id="{155286B2-0558-4696-8DE1-CD927815B46B}" type="datetimeFigureOut">
               <a:rPr lang="en-US" smtClean="0"/>
-              <a:t>1/23/2026</a:t>
+              <a:t>1/24/2026</a:t>
             </a:fld>
             <a:endParaRPr lang="en-US"/>
           </a:p>
@@ -463,7 +502,7 @@
           <a:p>
             <a:fld id="{155286B2-0558-4696-8DE1-CD927815B46B}" type="datetimeFigureOut">
               <a:rPr lang="en-US" smtClean="0"/>
-              <a:t>1/23/2026</a:t>
+              <a:t>1/24/2026</a:t>
             </a:fld>
             <a:endParaRPr lang="en-US"/>
           </a:p>
@@ -671,7 +710,7 @@
           <a:p>
             <a:fld id="{155286B2-0558-4696-8DE1-CD927815B46B}" type="datetimeFigureOut">
               <a:rPr lang="en-US" smtClean="0"/>
-              <a:t>1/23/2026</a:t>
+              <a:t>1/24/2026</a:t>
             </a:fld>
             <a:endParaRPr lang="en-US"/>
           </a:p>
@@ -869,7 +908,7 @@
           <a:p>
             <a:fld id="{155286B2-0558-4696-8DE1-CD927815B46B}" type="datetimeFigureOut">
               <a:rPr lang="en-US" smtClean="0"/>
-              <a:t>1/23/2026</a:t>
+              <a:t>1/24/2026</a:t>
             </a:fld>
             <a:endParaRPr lang="en-US"/>
           </a:p>
@@ -1144,7 +1183,7 @@
           <a:p>
             <a:fld id="{155286B2-0558-4696-8DE1-CD927815B46B}" type="datetimeFigureOut">
               <a:rPr lang="en-US" smtClean="0"/>
-              <a:t>1/23/2026</a:t>
+              <a:t>1/24/2026</a:t>
             </a:fld>
             <a:endParaRPr lang="en-US"/>
           </a:p>
@@ -1409,7 +1448,7 @@
           <a:p>
             <a:fld id="{155286B2-0558-4696-8DE1-CD927815B46B}" type="datetimeFigureOut">
               <a:rPr lang="en-US" smtClean="0"/>
-              <a:t>1/23/2026</a:t>
+              <a:t>1/24/2026</a:t>
             </a:fld>
             <a:endParaRPr lang="en-US"/>
           </a:p>
@@ -1821,7 +1860,7 @@
           <a:p>
             <a:fld id="{155286B2-0558-4696-8DE1-CD927815B46B}" type="datetimeFigureOut">
               <a:rPr lang="en-US" smtClean="0"/>
-              <a:t>1/23/2026</a:t>
+              <a:t>1/24/2026</a:t>
             </a:fld>
             <a:endParaRPr lang="en-US"/>
           </a:p>
@@ -1962,7 +2001,7 @@
           <a:p>
             <a:fld id="{155286B2-0558-4696-8DE1-CD927815B46B}" type="datetimeFigureOut">
               <a:rPr lang="en-US" smtClean="0"/>
-              <a:t>1/23/2026</a:t>
+              <a:t>1/24/2026</a:t>
             </a:fld>
             <a:endParaRPr lang="en-US"/>
           </a:p>
@@ -2075,7 +2114,7 @@
           <a:p>
             <a:fld id="{155286B2-0558-4696-8DE1-CD927815B46B}" type="datetimeFigureOut">
               <a:rPr lang="en-US" smtClean="0"/>
-              <a:t>1/23/2026</a:t>
+              <a:t>1/24/2026</a:t>
             </a:fld>
             <a:endParaRPr lang="en-US"/>
           </a:p>
@@ -2386,7 +2425,7 @@
           <a:p>
             <a:fld id="{155286B2-0558-4696-8DE1-CD927815B46B}" type="datetimeFigureOut">
               <a:rPr lang="en-US" smtClean="0"/>
-              <a:t>1/23/2026</a:t>
+              <a:t>1/24/2026</a:t>
             </a:fld>
             <a:endParaRPr lang="en-US"/>
           </a:p>
@@ -2674,7 +2713,7 @@
           <a:p>
             <a:fld id="{155286B2-0558-4696-8DE1-CD927815B46B}" type="datetimeFigureOut">
               <a:rPr lang="en-US" smtClean="0"/>
-              <a:t>1/23/2026</a:t>
+              <a:t>1/24/2026</a:t>
             </a:fld>
             <a:endParaRPr lang="en-US"/>
           </a:p>
@@ -2915,7 +2954,7 @@
           <a:p>
             <a:fld id="{155286B2-0558-4696-8DE1-CD927815B46B}" type="datetimeFigureOut">
               <a:rPr lang="en-US" smtClean="0"/>
-              <a:t>1/23/2026</a:t>
+              <a:t>1/24/2026</a:t>
             </a:fld>
             <a:endParaRPr lang="en-US"/>
           </a:p>
@@ -3407,6 +3446,944 @@
 </p:sld>
 </file>
 
+<file path=ppt/slides/slide10.xml><?xml version="1.0" encoding="utf-8"?>
+<p:sld xmlns:a="http://schemas.openxmlformats.org/drawingml/2006/main" xmlns:r="http://schemas.openxmlformats.org/officeDocument/2006/relationships" xmlns:p="http://schemas.openxmlformats.org/presentationml/2006/main">
+  <p:cSld>
+    <p:spTree>
+      <p:nvGrpSpPr>
+        <p:cNvPr id="1" name=""/>
+        <p:cNvGrpSpPr/>
+        <p:nvPr/>
+      </p:nvGrpSpPr>
+      <p:grpSpPr>
+        <a:xfrm>
+          <a:off x="0" y="0"/>
+          <a:ext cx="0" cy="0"/>
+          <a:chOff x="0" y="0"/>
+          <a:chExt cx="0" cy="0"/>
+        </a:xfrm>
+      </p:grpSpPr>
+      <p:sp>
+        <p:nvSpPr>
+          <p:cNvPr id="2" name="Title 1">
+            <a:extLst>
+              <a:ext uri="{FF2B5EF4-FFF2-40B4-BE49-F238E27FC236}">
+                <a16:creationId xmlns:a16="http://schemas.microsoft.com/office/drawing/2014/main" id="{6E3E17E1-D86C-31DC-0C1D-B558D61E8AC2}"/>
+              </a:ext>
+            </a:extLst>
+          </p:cNvPr>
+          <p:cNvSpPr>
+            <a:spLocks noGrp="1"/>
+          </p:cNvSpPr>
+          <p:nvPr>
+            <p:ph type="title"/>
+          </p:nvPr>
+        </p:nvSpPr>
+        <p:spPr/>
+        <p:txBody>
+          <a:bodyPr/>
+          <a:lstStyle/>
+          <a:p>
+            <a:r>
+              <a:rPr lang="en-US" dirty="0"/>
+              <a:t>EDA</a:t>
+            </a:r>
+          </a:p>
+        </p:txBody>
+      </p:sp>
+      <p:pic>
+        <p:nvPicPr>
+          <p:cNvPr id="5" name="Content Placeholder 4">
+            <a:extLst>
+              <a:ext uri="{FF2B5EF4-FFF2-40B4-BE49-F238E27FC236}">
+                <a16:creationId xmlns:a16="http://schemas.microsoft.com/office/drawing/2014/main" id="{8B43EEFD-C93D-50FA-D3AA-9D0ACFF14B13}"/>
+              </a:ext>
+            </a:extLst>
+          </p:cNvPr>
+          <p:cNvPicPr>
+            <a:picLocks noGrp="1" noChangeAspect="1"/>
+          </p:cNvPicPr>
+          <p:nvPr>
+            <p:ph idx="1"/>
+          </p:nvPr>
+        </p:nvPicPr>
+        <p:blipFill>
+          <a:blip r:embed="rId2"/>
+          <a:stretch>
+            <a:fillRect/>
+          </a:stretch>
+        </p:blipFill>
+        <p:spPr>
+          <a:xfrm>
+            <a:off x="838200" y="1222247"/>
+            <a:ext cx="5726420" cy="5270628"/>
+          </a:xfrm>
+          <a:prstGeom prst="rect">
+            <a:avLst/>
+          </a:prstGeom>
+        </p:spPr>
+      </p:pic>
+      <p:sp>
+        <p:nvSpPr>
+          <p:cNvPr id="8" name="TextBox 7">
+            <a:extLst>
+              <a:ext uri="{FF2B5EF4-FFF2-40B4-BE49-F238E27FC236}">
+                <a16:creationId xmlns:a16="http://schemas.microsoft.com/office/drawing/2014/main" id="{428C5F83-CC56-3C45-4581-3752C2F8FDBF}"/>
+              </a:ext>
+            </a:extLst>
+          </p:cNvPr>
+          <p:cNvSpPr txBox="1"/>
+          <p:nvPr/>
+        </p:nvSpPr>
+        <p:spPr>
+          <a:xfrm>
+            <a:off x="7362700" y="1448790"/>
+            <a:ext cx="4762287" cy="3693319"/>
+          </a:xfrm>
+          <a:prstGeom prst="rect">
+            <a:avLst/>
+          </a:prstGeom>
+          <a:noFill/>
+        </p:spPr>
+        <p:txBody>
+          <a:bodyPr wrap="square">
+            <a:spAutoFit/>
+          </a:bodyPr>
+          <a:lstStyle/>
+          <a:p>
+            <a:r>
+              <a:rPr lang="en-US" dirty="0"/>
+              <a:t>How do I inspect the outlier?</a:t>
+            </a:r>
+          </a:p>
+          <a:p>
+            <a:endParaRPr lang="en-US" dirty="0"/>
+          </a:p>
+          <a:p>
+            <a:r>
+              <a:rPr lang="en-US" dirty="0"/>
+              <a:t>relatively low rms </a:t>
+            </a:r>
+            <a:r>
+              <a:rPr lang="en-US" dirty="0">
+                <a:sym typeface="Wingdings" panose="05000000000000000000" pitchFamily="2" charset="2"/>
+              </a:rPr>
+              <a:t> </a:t>
+            </a:r>
+            <a:r>
+              <a:rPr lang="en-US" dirty="0"/>
+              <a:t>more recent last observation dates ?</a:t>
+            </a:r>
+          </a:p>
+          <a:p>
+            <a:endParaRPr lang="en-US" dirty="0"/>
+          </a:p>
+          <a:p>
+            <a:r>
+              <a:rPr lang="en-US" dirty="0"/>
+              <a:t>distribution of </a:t>
+            </a:r>
+            <a:r>
+              <a:rPr lang="en-US" dirty="0" err="1"/>
+              <a:t>last_obs</a:t>
+            </a:r>
+            <a:r>
+              <a:rPr lang="en-US" dirty="0"/>
+              <a:t> for low-rms objects is more tightly clustered </a:t>
+            </a:r>
+            <a:r>
+              <a:rPr lang="en-US" dirty="0">
+                <a:sym typeface="Wingdings" panose="05000000000000000000" pitchFamily="2" charset="2"/>
+              </a:rPr>
+              <a:t> </a:t>
+            </a:r>
+            <a:r>
+              <a:rPr lang="en-US" dirty="0"/>
+              <a:t>highly constrained orbits are typically associated with recent observations. </a:t>
+            </a:r>
+          </a:p>
+          <a:p>
+            <a:endParaRPr lang="en-US" dirty="0"/>
+          </a:p>
+          <a:p>
+            <a:r>
+              <a:rPr lang="en-US" dirty="0"/>
+              <a:t>Some low-rms objects have not been observed as recently </a:t>
+            </a:r>
+            <a:r>
+              <a:rPr lang="en-US" dirty="0">
+                <a:sym typeface="Wingdings" panose="05000000000000000000" pitchFamily="2" charset="2"/>
+              </a:rPr>
+              <a:t> </a:t>
+            </a:r>
+            <a:r>
+              <a:rPr lang="en-US" dirty="0"/>
+              <a:t>some orbits remain well-characterized over time.</a:t>
+            </a:r>
+          </a:p>
+        </p:txBody>
+      </p:sp>
+    </p:spTree>
+    <p:extLst>
+      <p:ext uri="{BB962C8B-B14F-4D97-AF65-F5344CB8AC3E}">
+        <p14:creationId xmlns:p14="http://schemas.microsoft.com/office/powerpoint/2010/main" val="1469715328"/>
+      </p:ext>
+    </p:extLst>
+  </p:cSld>
+  <p:clrMapOvr>
+    <a:masterClrMapping/>
+  </p:clrMapOvr>
+</p:sld>
+</file>
+
+<file path=ppt/slides/slide11.xml><?xml version="1.0" encoding="utf-8"?>
+<p:sld xmlns:a="http://schemas.openxmlformats.org/drawingml/2006/main" xmlns:r="http://schemas.openxmlformats.org/officeDocument/2006/relationships" xmlns:p="http://schemas.openxmlformats.org/presentationml/2006/main">
+  <p:cSld>
+    <p:spTree>
+      <p:nvGrpSpPr>
+        <p:cNvPr id="1" name=""/>
+        <p:cNvGrpSpPr/>
+        <p:nvPr/>
+      </p:nvGrpSpPr>
+      <p:grpSpPr>
+        <a:xfrm>
+          <a:off x="0" y="0"/>
+          <a:ext cx="0" cy="0"/>
+          <a:chOff x="0" y="0"/>
+          <a:chExt cx="0" cy="0"/>
+        </a:xfrm>
+      </p:grpSpPr>
+      <p:pic>
+        <p:nvPicPr>
+          <p:cNvPr id="12" name="Content Placeholder 11">
+            <a:extLst>
+              <a:ext uri="{FF2B5EF4-FFF2-40B4-BE49-F238E27FC236}">
+                <a16:creationId xmlns:a16="http://schemas.microsoft.com/office/drawing/2014/main" id="{D64EC159-563C-FF01-E337-836CF8FC4645}"/>
+              </a:ext>
+            </a:extLst>
+          </p:cNvPr>
+          <p:cNvPicPr>
+            <a:picLocks noGrp="1" noChangeAspect="1"/>
+          </p:cNvPicPr>
+          <p:nvPr>
+            <p:ph idx="1"/>
+          </p:nvPr>
+        </p:nvPicPr>
+        <p:blipFill>
+          <a:blip r:embed="rId2"/>
+          <a:stretch>
+            <a:fillRect/>
+          </a:stretch>
+        </p:blipFill>
+        <p:spPr>
+          <a:xfrm>
+            <a:off x="178130" y="408285"/>
+            <a:ext cx="7184571" cy="5859263"/>
+          </a:xfrm>
+          <a:prstGeom prst="rect">
+            <a:avLst/>
+          </a:prstGeom>
+        </p:spPr>
+      </p:pic>
+      <p:sp>
+        <p:nvSpPr>
+          <p:cNvPr id="7" name="TextBox 6">
+            <a:extLst>
+              <a:ext uri="{FF2B5EF4-FFF2-40B4-BE49-F238E27FC236}">
+                <a16:creationId xmlns:a16="http://schemas.microsoft.com/office/drawing/2014/main" id="{6C2A191F-4C22-A14E-BC06-803ACE96A7AD}"/>
+              </a:ext>
+            </a:extLst>
+          </p:cNvPr>
+          <p:cNvSpPr txBox="1"/>
+          <p:nvPr/>
+        </p:nvSpPr>
+        <p:spPr>
+          <a:xfrm>
+            <a:off x="7321583" y="3849029"/>
+            <a:ext cx="4692287" cy="1754326"/>
+          </a:xfrm>
+          <a:prstGeom prst="rect">
+            <a:avLst/>
+          </a:prstGeom>
+          <a:noFill/>
+        </p:spPr>
+        <p:txBody>
+          <a:bodyPr wrap="square" rtlCol="0">
+            <a:spAutoFit/>
+          </a:bodyPr>
+          <a:lstStyle/>
+          <a:p>
+            <a:r>
+              <a:rPr lang="en-US" dirty="0"/>
+              <a:t>Increase limit from 100 to 1000 records, highlight rms in the 5</a:t>
+            </a:r>
+            <a:r>
+              <a:rPr lang="en-US" baseline="30000" dirty="0"/>
+              <a:t>th</a:t>
+            </a:r>
+            <a:r>
+              <a:rPr lang="en-US" dirty="0"/>
+              <a:t> percentile (red)</a:t>
+            </a:r>
+          </a:p>
+          <a:p>
+            <a:endParaRPr lang="en-US" dirty="0"/>
+          </a:p>
+          <a:p>
+            <a:r>
+              <a:rPr lang="en-US" dirty="0"/>
+              <a:t>Expected to see a downward trend indicating an inverse relationship between observation arc length and rms, but it doesn’t appear.</a:t>
+            </a:r>
+          </a:p>
+        </p:txBody>
+      </p:sp>
+      <p:pic>
+        <p:nvPicPr>
+          <p:cNvPr id="9" name="Picture 8">
+            <a:extLst>
+              <a:ext uri="{FF2B5EF4-FFF2-40B4-BE49-F238E27FC236}">
+                <a16:creationId xmlns:a16="http://schemas.microsoft.com/office/drawing/2014/main" id="{72C96C8B-F431-73A2-15B6-BA90AC1D0D4F}"/>
+              </a:ext>
+            </a:extLst>
+          </p:cNvPr>
+          <p:cNvPicPr>
+            <a:picLocks noChangeAspect="1"/>
+          </p:cNvPicPr>
+          <p:nvPr/>
+        </p:nvPicPr>
+        <p:blipFill>
+          <a:blip r:embed="rId3"/>
+          <a:stretch>
+            <a:fillRect/>
+          </a:stretch>
+        </p:blipFill>
+        <p:spPr>
+          <a:xfrm>
+            <a:off x="6779756" y="528107"/>
+            <a:ext cx="5412244" cy="3201100"/>
+          </a:xfrm>
+          <a:prstGeom prst="rect">
+            <a:avLst/>
+          </a:prstGeom>
+        </p:spPr>
+      </p:pic>
+    </p:spTree>
+    <p:extLst>
+      <p:ext uri="{BB962C8B-B14F-4D97-AF65-F5344CB8AC3E}">
+        <p14:creationId xmlns:p14="http://schemas.microsoft.com/office/powerpoint/2010/main" val="3582324190"/>
+      </p:ext>
+    </p:extLst>
+  </p:cSld>
+  <p:clrMapOvr>
+    <a:masterClrMapping/>
+  </p:clrMapOvr>
+</p:sld>
+</file>
+
+<file path=ppt/slides/slide12.xml><?xml version="1.0" encoding="utf-8"?>
+<p:sld xmlns:a="http://schemas.openxmlformats.org/drawingml/2006/main" xmlns:r="http://schemas.openxmlformats.org/officeDocument/2006/relationships" xmlns:p="http://schemas.openxmlformats.org/presentationml/2006/main">
+  <p:cSld>
+    <p:spTree>
+      <p:nvGrpSpPr>
+        <p:cNvPr id="1" name=""/>
+        <p:cNvGrpSpPr/>
+        <p:nvPr/>
+      </p:nvGrpSpPr>
+      <p:grpSpPr>
+        <a:xfrm>
+          <a:off x="0" y="0"/>
+          <a:ext cx="0" cy="0"/>
+          <a:chOff x="0" y="0"/>
+          <a:chExt cx="0" cy="0"/>
+        </a:xfrm>
+      </p:grpSpPr>
+      <p:sp>
+        <p:nvSpPr>
+          <p:cNvPr id="2" name="Title 1">
+            <a:extLst>
+              <a:ext uri="{FF2B5EF4-FFF2-40B4-BE49-F238E27FC236}">
+                <a16:creationId xmlns:a16="http://schemas.microsoft.com/office/drawing/2014/main" id="{801A203C-C4D3-DA1E-9FE3-8F0AA30BD009}"/>
+              </a:ext>
+            </a:extLst>
+          </p:cNvPr>
+          <p:cNvSpPr>
+            <a:spLocks noGrp="1"/>
+          </p:cNvSpPr>
+          <p:nvPr>
+            <p:ph type="title"/>
+          </p:nvPr>
+        </p:nvSpPr>
+        <p:spPr/>
+        <p:txBody>
+          <a:bodyPr/>
+          <a:lstStyle/>
+          <a:p>
+            <a:r>
+              <a:rPr lang="en-US" dirty="0"/>
+              <a:t>Obstacles</a:t>
+            </a:r>
+          </a:p>
+        </p:txBody>
+      </p:sp>
+      <p:sp>
+        <p:nvSpPr>
+          <p:cNvPr id="3" name="Content Placeholder 2">
+            <a:extLst>
+              <a:ext uri="{FF2B5EF4-FFF2-40B4-BE49-F238E27FC236}">
+                <a16:creationId xmlns:a16="http://schemas.microsoft.com/office/drawing/2014/main" id="{97443D9C-B23B-A2B4-72BA-D1F11835FA77}"/>
+              </a:ext>
+            </a:extLst>
+          </p:cNvPr>
+          <p:cNvSpPr>
+            <a:spLocks noGrp="1"/>
+          </p:cNvSpPr>
+          <p:nvPr>
+            <p:ph idx="1"/>
+          </p:nvPr>
+        </p:nvSpPr>
+        <p:spPr>
+          <a:xfrm>
+            <a:off x="838200" y="1825625"/>
+            <a:ext cx="10515600" cy="1325563"/>
+          </a:xfrm>
+        </p:spPr>
+        <p:txBody>
+          <a:bodyPr>
+            <a:normAutofit fontScale="70000" lnSpcReduction="20000"/>
+          </a:bodyPr>
+          <a:lstStyle/>
+          <a:p>
+            <a:pPr marL="0" indent="0">
+              <a:buNone/>
+            </a:pPr>
+            <a:r>
+              <a:rPr lang="en-US" dirty="0"/>
+              <a:t>Some columns are stored as lists due to missing values in the API response. </a:t>
+            </a:r>
+            <a:r>
+              <a:rPr lang="en-US" dirty="0" err="1"/>
+              <a:t>unlist</a:t>
+            </a:r>
+            <a:r>
+              <a:rPr lang="en-US" dirty="0"/>
+              <a:t>() flattens each column into a standard atomic vector, required before converting data types.</a:t>
+            </a:r>
+          </a:p>
+          <a:p>
+            <a:pPr marL="0" indent="0">
+              <a:buNone/>
+            </a:pPr>
+            <a:r>
+              <a:rPr lang="en-US" dirty="0" err="1"/>
+              <a:t>na_if</a:t>
+            </a:r>
+            <a:r>
+              <a:rPr lang="en-US" dirty="0"/>
+              <a:t>() replaces the N/A values with blanks</a:t>
+            </a:r>
+          </a:p>
+          <a:p>
+            <a:pPr marL="0" indent="0">
+              <a:buNone/>
+            </a:pPr>
+            <a:r>
+              <a:rPr lang="en-US" dirty="0" err="1"/>
+              <a:t>as.Date</a:t>
+            </a:r>
+            <a:r>
+              <a:rPr lang="en-US" dirty="0"/>
+              <a:t>() is important to be able to plot values versus date, in order from earliest to latest</a:t>
+            </a:r>
+          </a:p>
+        </p:txBody>
+      </p:sp>
+      <p:pic>
+        <p:nvPicPr>
+          <p:cNvPr id="5" name="Picture 4">
+            <a:extLst>
+              <a:ext uri="{FF2B5EF4-FFF2-40B4-BE49-F238E27FC236}">
+                <a16:creationId xmlns:a16="http://schemas.microsoft.com/office/drawing/2014/main" id="{A7937A59-ECED-B68E-79DE-16D574D1BB00}"/>
+              </a:ext>
+            </a:extLst>
+          </p:cNvPr>
+          <p:cNvPicPr>
+            <a:picLocks noChangeAspect="1"/>
+          </p:cNvPicPr>
+          <p:nvPr/>
+        </p:nvPicPr>
+        <p:blipFill>
+          <a:blip r:embed="rId2"/>
+          <a:stretch>
+            <a:fillRect/>
+          </a:stretch>
+        </p:blipFill>
+        <p:spPr>
+          <a:xfrm>
+            <a:off x="838200" y="3286125"/>
+            <a:ext cx="4970560" cy="2956467"/>
+          </a:xfrm>
+          <a:prstGeom prst="rect">
+            <a:avLst/>
+          </a:prstGeom>
+        </p:spPr>
+      </p:pic>
+      <p:pic>
+        <p:nvPicPr>
+          <p:cNvPr id="7" name="Picture 6">
+            <a:extLst>
+              <a:ext uri="{FF2B5EF4-FFF2-40B4-BE49-F238E27FC236}">
+                <a16:creationId xmlns:a16="http://schemas.microsoft.com/office/drawing/2014/main" id="{824D7470-9330-4DAF-8492-D338D545F659}"/>
+              </a:ext>
+            </a:extLst>
+          </p:cNvPr>
+          <p:cNvPicPr>
+            <a:picLocks noChangeAspect="1"/>
+          </p:cNvPicPr>
+          <p:nvPr/>
+        </p:nvPicPr>
+        <p:blipFill>
+          <a:blip r:embed="rId3"/>
+          <a:stretch>
+            <a:fillRect/>
+          </a:stretch>
+        </p:blipFill>
+        <p:spPr>
+          <a:xfrm>
+            <a:off x="6096000" y="3429000"/>
+            <a:ext cx="5616877" cy="2437781"/>
+          </a:xfrm>
+          <a:prstGeom prst="rect">
+            <a:avLst/>
+          </a:prstGeom>
+        </p:spPr>
+      </p:pic>
+    </p:spTree>
+    <p:extLst>
+      <p:ext uri="{BB962C8B-B14F-4D97-AF65-F5344CB8AC3E}">
+        <p14:creationId xmlns:p14="http://schemas.microsoft.com/office/powerpoint/2010/main" val="1825110092"/>
+      </p:ext>
+    </p:extLst>
+  </p:cSld>
+  <p:clrMapOvr>
+    <a:masterClrMapping/>
+  </p:clrMapOvr>
+</p:sld>
+</file>
+
+<file path=ppt/slides/slide13.xml><?xml version="1.0" encoding="utf-8"?>
+<p:sld xmlns:a="http://schemas.openxmlformats.org/drawingml/2006/main" xmlns:r="http://schemas.openxmlformats.org/officeDocument/2006/relationships" xmlns:p="http://schemas.openxmlformats.org/presentationml/2006/main">
+  <p:cSld>
+    <p:spTree>
+      <p:nvGrpSpPr>
+        <p:cNvPr id="1" name=""/>
+        <p:cNvGrpSpPr/>
+        <p:nvPr/>
+      </p:nvGrpSpPr>
+      <p:grpSpPr>
+        <a:xfrm>
+          <a:off x="0" y="0"/>
+          <a:ext cx="0" cy="0"/>
+          <a:chOff x="0" y="0"/>
+          <a:chExt cx="0" cy="0"/>
+        </a:xfrm>
+      </p:grpSpPr>
+      <p:sp>
+        <p:nvSpPr>
+          <p:cNvPr id="2" name="Title 1">
+            <a:extLst>
+              <a:ext uri="{FF2B5EF4-FFF2-40B4-BE49-F238E27FC236}">
+                <a16:creationId xmlns:a16="http://schemas.microsoft.com/office/drawing/2014/main" id="{675E971B-6B6F-AAA0-EB52-A0EDD000A7C7}"/>
+              </a:ext>
+            </a:extLst>
+          </p:cNvPr>
+          <p:cNvSpPr>
+            <a:spLocks noGrp="1"/>
+          </p:cNvSpPr>
+          <p:nvPr>
+            <p:ph type="title"/>
+          </p:nvPr>
+        </p:nvSpPr>
+        <p:spPr/>
+        <p:txBody>
+          <a:bodyPr/>
+          <a:lstStyle/>
+          <a:p>
+            <a:r>
+              <a:rPr lang="en-US" dirty="0"/>
+              <a:t>Takeaways and Questions</a:t>
+            </a:r>
+          </a:p>
+        </p:txBody>
+      </p:sp>
+      <p:sp>
+        <p:nvSpPr>
+          <p:cNvPr id="3" name="Content Placeholder 2">
+            <a:extLst>
+              <a:ext uri="{FF2B5EF4-FFF2-40B4-BE49-F238E27FC236}">
+                <a16:creationId xmlns:a16="http://schemas.microsoft.com/office/drawing/2014/main" id="{49A55EF3-392C-F216-FCD1-5B39B939C1D7}"/>
+              </a:ext>
+            </a:extLst>
+          </p:cNvPr>
+          <p:cNvSpPr>
+            <a:spLocks noGrp="1"/>
+          </p:cNvSpPr>
+          <p:nvPr>
+            <p:ph idx="1"/>
+          </p:nvPr>
+        </p:nvSpPr>
+        <p:spPr/>
+        <p:txBody>
+          <a:bodyPr>
+            <a:normAutofit fontScale="92500" lnSpcReduction="10000"/>
+          </a:bodyPr>
+          <a:lstStyle/>
+          <a:p>
+            <a:r>
+              <a:rPr lang="en-US" sz="2400" dirty="0"/>
+              <a:t>What do we do about data that is not clean, in an unpredicted way? Like this:</a:t>
+            </a:r>
+          </a:p>
+          <a:p>
+            <a:endParaRPr lang="en-US" sz="2400" dirty="0"/>
+          </a:p>
+          <a:p>
+            <a:endParaRPr lang="en-US" sz="2400" dirty="0"/>
+          </a:p>
+          <a:p>
+            <a:endParaRPr lang="en-US" sz="2400" dirty="0"/>
+          </a:p>
+          <a:p>
+            <a:endParaRPr lang="en-US" sz="2400" dirty="0"/>
+          </a:p>
+          <a:p>
+            <a:endParaRPr lang="en-US" sz="2400" dirty="0"/>
+          </a:p>
+          <a:p>
+            <a:endParaRPr lang="en-US" sz="2400" dirty="0"/>
+          </a:p>
+          <a:p>
+            <a:endParaRPr lang="en-US" sz="2400" dirty="0"/>
+          </a:p>
+          <a:p>
+            <a:r>
+              <a:rPr lang="en-US" sz="2400" dirty="0"/>
+              <a:t>Searching “sushi” </a:t>
+            </a:r>
+            <a:r>
+              <a:rPr lang="en-US" sz="2400" dirty="0">
+                <a:sym typeface="Wingdings" panose="05000000000000000000" pitchFamily="2" charset="2"/>
+              </a:rPr>
+              <a:t> cannot find </a:t>
+            </a:r>
+            <a:r>
+              <a:rPr lang="en-US" sz="2400" dirty="0"/>
+              <a:t>“sush1” , “</a:t>
+            </a:r>
+            <a:r>
+              <a:rPr lang="en-US" sz="2400" dirty="0" err="1"/>
+              <a:t>sushee</a:t>
+            </a:r>
+            <a:r>
+              <a:rPr lang="en-US" sz="2400" dirty="0"/>
+              <a:t>” ,“</a:t>
+            </a:r>
+            <a:r>
+              <a:rPr lang="en-US" sz="2400" dirty="0" err="1"/>
+              <a:t>sooshee</a:t>
+            </a:r>
+            <a:r>
+              <a:rPr lang="en-US" sz="2400" dirty="0"/>
+              <a:t>” , “King’s Sashimi Palace”</a:t>
+            </a:r>
+          </a:p>
+          <a:p>
+            <a:r>
+              <a:rPr lang="en-US" sz="2400" dirty="0"/>
+              <a:t>Searching “café” </a:t>
+            </a:r>
+            <a:r>
+              <a:rPr lang="en-US" sz="2400" dirty="0">
+                <a:sym typeface="Wingdings" panose="05000000000000000000" pitchFamily="2" charset="2"/>
+              </a:rPr>
+              <a:t> cannot find GALLERY CAF0</a:t>
+            </a:r>
+            <a:endParaRPr lang="en-US" sz="2400" dirty="0"/>
+          </a:p>
+        </p:txBody>
+      </p:sp>
+      <p:pic>
+        <p:nvPicPr>
+          <p:cNvPr id="5" name="Picture 4">
+            <a:extLst>
+              <a:ext uri="{FF2B5EF4-FFF2-40B4-BE49-F238E27FC236}">
+                <a16:creationId xmlns:a16="http://schemas.microsoft.com/office/drawing/2014/main" id="{6CFDC095-1442-3598-0202-37A3B12FE5D2}"/>
+              </a:ext>
+            </a:extLst>
+          </p:cNvPr>
+          <p:cNvPicPr>
+            <a:picLocks noChangeAspect="1"/>
+          </p:cNvPicPr>
+          <p:nvPr/>
+        </p:nvPicPr>
+        <p:blipFill>
+          <a:blip r:embed="rId2"/>
+          <a:stretch>
+            <a:fillRect/>
+          </a:stretch>
+        </p:blipFill>
+        <p:spPr>
+          <a:xfrm>
+            <a:off x="3489830" y="2282514"/>
+            <a:ext cx="5001323" cy="2715004"/>
+          </a:xfrm>
+          <a:prstGeom prst="rect">
+            <a:avLst/>
+          </a:prstGeom>
+        </p:spPr>
+      </p:pic>
+    </p:spTree>
+    <p:extLst>
+      <p:ext uri="{BB962C8B-B14F-4D97-AF65-F5344CB8AC3E}">
+        <p14:creationId xmlns:p14="http://schemas.microsoft.com/office/powerpoint/2010/main" val="845736422"/>
+      </p:ext>
+    </p:extLst>
+  </p:cSld>
+  <p:clrMapOvr>
+    <a:masterClrMapping/>
+  </p:clrMapOvr>
+</p:sld>
+</file>
+
+<file path=ppt/slides/slide14.xml><?xml version="1.0" encoding="utf-8"?>
+<p:sld xmlns:a="http://schemas.openxmlformats.org/drawingml/2006/main" xmlns:r="http://schemas.openxmlformats.org/officeDocument/2006/relationships" xmlns:p="http://schemas.openxmlformats.org/presentationml/2006/main">
+  <p:cSld>
+    <p:spTree>
+      <p:nvGrpSpPr>
+        <p:cNvPr id="1" name=""/>
+        <p:cNvGrpSpPr/>
+        <p:nvPr/>
+      </p:nvGrpSpPr>
+      <p:grpSpPr>
+        <a:xfrm>
+          <a:off x="0" y="0"/>
+          <a:ext cx="0" cy="0"/>
+          <a:chOff x="0" y="0"/>
+          <a:chExt cx="0" cy="0"/>
+        </a:xfrm>
+      </p:grpSpPr>
+      <p:sp>
+        <p:nvSpPr>
+          <p:cNvPr id="2" name="Title 1">
+            <a:extLst>
+              <a:ext uri="{FF2B5EF4-FFF2-40B4-BE49-F238E27FC236}">
+                <a16:creationId xmlns:a16="http://schemas.microsoft.com/office/drawing/2014/main" id="{05947BDF-309D-C75A-ED9C-A2EC8969C1BA}"/>
+              </a:ext>
+            </a:extLst>
+          </p:cNvPr>
+          <p:cNvSpPr>
+            <a:spLocks noGrp="1"/>
+          </p:cNvSpPr>
+          <p:nvPr>
+            <p:ph type="title"/>
+          </p:nvPr>
+        </p:nvSpPr>
+        <p:spPr/>
+        <p:txBody>
+          <a:bodyPr/>
+          <a:lstStyle/>
+          <a:p>
+            <a:r>
+              <a:rPr lang="en-US" dirty="0"/>
+              <a:t>Questions	</a:t>
+            </a:r>
+          </a:p>
+        </p:txBody>
+      </p:sp>
+      <p:sp>
+        <p:nvSpPr>
+          <p:cNvPr id="3" name="Content Placeholder 2">
+            <a:extLst>
+              <a:ext uri="{FF2B5EF4-FFF2-40B4-BE49-F238E27FC236}">
+                <a16:creationId xmlns:a16="http://schemas.microsoft.com/office/drawing/2014/main" id="{62B35EE9-E072-93EE-2C65-83407E8C4F3A}"/>
+              </a:ext>
+            </a:extLst>
+          </p:cNvPr>
+          <p:cNvSpPr>
+            <a:spLocks noGrp="1"/>
+          </p:cNvSpPr>
+          <p:nvPr>
+            <p:ph idx="1"/>
+          </p:nvPr>
+        </p:nvSpPr>
+        <p:spPr/>
+        <p:txBody>
+          <a:bodyPr/>
+          <a:lstStyle/>
+          <a:p>
+            <a:r>
+              <a:rPr lang="en-US" dirty="0"/>
+              <a:t>Gather Spread and Separate: How does it know to separate based on the delimiting character?</a:t>
+            </a:r>
+          </a:p>
+          <a:p>
+            <a:r>
+              <a:rPr lang="en-US" dirty="0"/>
+              <a:t>API key: How come I registered for an API key for the NASA </a:t>
+            </a:r>
+            <a:r>
+              <a:rPr lang="en-US" dirty="0" err="1"/>
+              <a:t>db</a:t>
+            </a:r>
+            <a:r>
+              <a:rPr lang="en-US" dirty="0"/>
+              <a:t>, but didn’t have to use it to make a successful GET request?</a:t>
+            </a:r>
+          </a:p>
+          <a:p>
+            <a:r>
+              <a:rPr lang="en-US" dirty="0"/>
+              <a:t>grep: Why does </a:t>
+            </a:r>
+            <a:r>
+              <a:rPr lang="en-US" dirty="0" err="1"/>
+              <a:t>ignore.case</a:t>
+            </a:r>
+            <a:r>
+              <a:rPr lang="en-US" dirty="0"/>
+              <a:t> not work as expected here?</a:t>
+            </a:r>
+          </a:p>
+          <a:p>
+            <a:endParaRPr lang="en-US" dirty="0"/>
+          </a:p>
+        </p:txBody>
+      </p:sp>
+      <p:pic>
+        <p:nvPicPr>
+          <p:cNvPr id="5" name="Content Placeholder 4">
+            <a:extLst>
+              <a:ext uri="{FF2B5EF4-FFF2-40B4-BE49-F238E27FC236}">
+                <a16:creationId xmlns:a16="http://schemas.microsoft.com/office/drawing/2014/main" id="{91FFEEFC-CD97-5AF2-4BB5-208E3D04AB86}"/>
+              </a:ext>
+            </a:extLst>
+          </p:cNvPr>
+          <p:cNvPicPr>
+            <a:picLocks noChangeAspect="1"/>
+          </p:cNvPicPr>
+          <p:nvPr/>
+        </p:nvPicPr>
+        <p:blipFill>
+          <a:blip r:embed="rId2"/>
+          <a:stretch>
+            <a:fillRect/>
+          </a:stretch>
+        </p:blipFill>
+        <p:spPr>
+          <a:xfrm>
+            <a:off x="3269231" y="4221078"/>
+            <a:ext cx="5653537" cy="2378674"/>
+          </a:xfrm>
+          <a:prstGeom prst="rect">
+            <a:avLst/>
+          </a:prstGeom>
+        </p:spPr>
+      </p:pic>
+    </p:spTree>
+    <p:extLst>
+      <p:ext uri="{BB962C8B-B14F-4D97-AF65-F5344CB8AC3E}">
+        <p14:creationId xmlns:p14="http://schemas.microsoft.com/office/powerpoint/2010/main" val="3585677060"/>
+      </p:ext>
+    </p:extLst>
+  </p:cSld>
+  <p:clrMapOvr>
+    <a:masterClrMapping/>
+  </p:clrMapOvr>
+</p:sld>
+</file>
+
+<file path=ppt/slides/slide15.xml><?xml version="1.0" encoding="utf-8"?>
+<p:sld xmlns:a="http://schemas.openxmlformats.org/drawingml/2006/main" xmlns:r="http://schemas.openxmlformats.org/officeDocument/2006/relationships" xmlns:p="http://schemas.openxmlformats.org/presentationml/2006/main">
+  <p:cSld>
+    <p:spTree>
+      <p:nvGrpSpPr>
+        <p:cNvPr id="1" name=""/>
+        <p:cNvGrpSpPr/>
+        <p:nvPr/>
+      </p:nvGrpSpPr>
+      <p:grpSpPr>
+        <a:xfrm>
+          <a:off x="0" y="0"/>
+          <a:ext cx="0" cy="0"/>
+          <a:chOff x="0" y="0"/>
+          <a:chExt cx="0" cy="0"/>
+        </a:xfrm>
+      </p:grpSpPr>
+      <p:sp>
+        <p:nvSpPr>
+          <p:cNvPr id="2" name="Title 1">
+            <a:extLst>
+              <a:ext uri="{FF2B5EF4-FFF2-40B4-BE49-F238E27FC236}">
+                <a16:creationId xmlns:a16="http://schemas.microsoft.com/office/drawing/2014/main" id="{A6193C25-96B1-4C6E-E127-BE0E99C73D50}"/>
+              </a:ext>
+            </a:extLst>
+          </p:cNvPr>
+          <p:cNvSpPr>
+            <a:spLocks noGrp="1"/>
+          </p:cNvSpPr>
+          <p:nvPr>
+            <p:ph type="title"/>
+          </p:nvPr>
+        </p:nvSpPr>
+        <p:spPr/>
+        <p:txBody>
+          <a:bodyPr/>
+          <a:lstStyle/>
+          <a:p>
+            <a:endParaRPr lang="en-US"/>
+          </a:p>
+        </p:txBody>
+      </p:sp>
+      <p:sp>
+        <p:nvSpPr>
+          <p:cNvPr id="3" name="Content Placeholder 2">
+            <a:extLst>
+              <a:ext uri="{FF2B5EF4-FFF2-40B4-BE49-F238E27FC236}">
+                <a16:creationId xmlns:a16="http://schemas.microsoft.com/office/drawing/2014/main" id="{47C74610-BAA0-ED44-BECE-6C15800C934B}"/>
+              </a:ext>
+            </a:extLst>
+          </p:cNvPr>
+          <p:cNvSpPr>
+            <a:spLocks noGrp="1"/>
+          </p:cNvSpPr>
+          <p:nvPr>
+            <p:ph idx="1"/>
+          </p:nvPr>
+        </p:nvSpPr>
+        <p:spPr/>
+        <p:txBody>
+          <a:bodyPr/>
+          <a:lstStyle/>
+          <a:p>
+            <a:r>
+              <a:rPr lang="en-US" dirty="0"/>
+              <a:t>How do I write a hypothesis when I’m looking for a correlation between two variables?</a:t>
+            </a:r>
+          </a:p>
+        </p:txBody>
+      </p:sp>
+    </p:spTree>
+    <p:extLst>
+      <p:ext uri="{BB962C8B-B14F-4D97-AF65-F5344CB8AC3E}">
+        <p14:creationId xmlns:p14="http://schemas.microsoft.com/office/powerpoint/2010/main" val="2445537954"/>
+      </p:ext>
+    </p:extLst>
+  </p:cSld>
+  <p:clrMapOvr>
+    <a:masterClrMapping/>
+  </p:clrMapOvr>
+</p:sld>
+</file>
+
 <file path=ppt/slides/slide2.xml><?xml version="1.0" encoding="utf-8"?>
 <p:sld xmlns:a="http://schemas.openxmlformats.org/drawingml/2006/main" xmlns:r="http://schemas.openxmlformats.org/officeDocument/2006/relationships" xmlns:p="http://schemas.openxmlformats.org/presentationml/2006/main">
   <p:cSld>
@@ -3429,7 +4406,7 @@
           <p:cNvPr id="2" name="Title 1">
             <a:extLst>
               <a:ext uri="{FF2B5EF4-FFF2-40B4-BE49-F238E27FC236}">
-                <a16:creationId xmlns:a16="http://schemas.microsoft.com/office/drawing/2014/main" id="{99DC9DA0-19AF-3401-F61B-E229E0D49534}"/>
+                <a16:creationId xmlns:a16="http://schemas.microsoft.com/office/drawing/2014/main" id="{2CD61229-B8D8-2937-2697-CF10755E63C8}"/>
               </a:ext>
             </a:extLst>
           </p:cNvPr>
@@ -3442,188 +4419,70 @@
         </p:nvSpPr>
         <p:spPr/>
         <p:txBody>
-          <a:bodyPr/>
+          <a:bodyPr>
+            <a:normAutofit fontScale="90000"/>
+          </a:bodyPr>
           <a:lstStyle/>
           <a:p>
             <a:r>
               <a:rPr lang="en-US" dirty="0"/>
-              <a:t>Web Scraping</a:t>
-            </a:r>
-          </a:p>
-        </p:txBody>
-      </p:sp>
-      <p:sp>
-        <p:nvSpPr>
-          <p:cNvPr id="4" name="TextBox 3">
-            <a:extLst>
-              <a:ext uri="{FF2B5EF4-FFF2-40B4-BE49-F238E27FC236}">
-                <a16:creationId xmlns:a16="http://schemas.microsoft.com/office/drawing/2014/main" id="{1088129B-A4CB-3321-5765-DB7C1EBFBE51}"/>
-              </a:ext>
-            </a:extLst>
-          </p:cNvPr>
-          <p:cNvSpPr txBox="1"/>
-          <p:nvPr/>
-        </p:nvSpPr>
+              <a:t>Scrape the XML page for name, </a:t>
+            </a:r>
+            <a:r>
+              <a:rPr lang="en-US" dirty="0" err="1"/>
+              <a:t>zipcode</a:t>
+            </a:r>
+            <a:r>
+              <a:rPr lang="en-US" dirty="0"/>
+              <a:t> and city council district.  (Use either the XML or </a:t>
+            </a:r>
+            <a:r>
+              <a:rPr lang="en-US" dirty="0" err="1"/>
+              <a:t>rvest</a:t>
+            </a:r>
+            <a:r>
+              <a:rPr lang="en-US" dirty="0"/>
+              <a:t> package.)</a:t>
+            </a:r>
+          </a:p>
+        </p:txBody>
+      </p:sp>
+      <p:pic>
+        <p:nvPicPr>
+          <p:cNvPr id="9" name="Content Placeholder 8">
+            <a:extLst>
+              <a:ext uri="{FF2B5EF4-FFF2-40B4-BE49-F238E27FC236}">
+                <a16:creationId xmlns:a16="http://schemas.microsoft.com/office/drawing/2014/main" id="{82ADB312-793B-99DA-0EA0-E6F3348A69E3}"/>
+              </a:ext>
+            </a:extLst>
+          </p:cNvPr>
+          <p:cNvPicPr>
+            <a:picLocks noGrp="1" noChangeAspect="1"/>
+          </p:cNvPicPr>
+          <p:nvPr>
+            <p:ph idx="1"/>
+          </p:nvPr>
+        </p:nvPicPr>
+        <p:blipFill>
+          <a:blip r:embed="rId2"/>
+          <a:stretch>
+            <a:fillRect/>
+          </a:stretch>
+        </p:blipFill>
         <p:spPr>
           <a:xfrm>
-            <a:off x="838201" y="1825626"/>
-            <a:ext cx="3030414" cy="4893647"/>
+            <a:off x="2500421" y="1825625"/>
+            <a:ext cx="7191158" cy="4351338"/>
           </a:xfrm>
           <a:prstGeom prst="rect">
             <a:avLst/>
           </a:prstGeom>
-          <a:noFill/>
         </p:spPr>
-        <p:txBody>
-          <a:bodyPr wrap="square" rtlCol="0">
-            <a:spAutoFit/>
-          </a:bodyPr>
-          <a:lstStyle/>
-          <a:p>
-            <a:r>
-              <a:rPr lang="en-US" sz="2400" dirty="0"/>
-              <a:t>Run the example code in the file Unit 4 Web </a:t>
-            </a:r>
-            <a:r>
-              <a:rPr lang="en-US" sz="2400" dirty="0" err="1"/>
-              <a:t>Scraping.R</a:t>
-            </a:r>
-            <a:r>
-              <a:rPr lang="en-US" sz="2400" dirty="0"/>
-              <a:t>  This will help tremendously with the web scraping in Part 1.  You will have to learn the grep and </a:t>
-            </a:r>
-            <a:r>
-              <a:rPr lang="en-US" sz="2400" dirty="0" err="1"/>
-              <a:t>grepl</a:t>
-            </a:r>
-            <a:r>
-              <a:rPr lang="en-US" sz="2400" dirty="0"/>
-              <a:t> functions which I think you will find very useful and we will extend on in the future.   (1 hour)</a:t>
-            </a:r>
-          </a:p>
-        </p:txBody>
-      </p:sp>
-      <p:sp>
-        <p:nvSpPr>
-          <p:cNvPr id="5" name="Content Placeholder 2">
-            <a:extLst>
-              <a:ext uri="{FF2B5EF4-FFF2-40B4-BE49-F238E27FC236}">
-                <a16:creationId xmlns:a16="http://schemas.microsoft.com/office/drawing/2014/main" id="{8E995449-B9AD-E3C8-C39B-63BCFE9E2189}"/>
-              </a:ext>
-            </a:extLst>
-          </p:cNvPr>
-          <p:cNvSpPr>
-            <a:spLocks noGrp="1"/>
-          </p:cNvSpPr>
-          <p:nvPr>
-            <p:ph idx="1"/>
-          </p:nvPr>
-        </p:nvSpPr>
-        <p:spPr>
-          <a:xfrm>
-            <a:off x="3868615" y="1825625"/>
-            <a:ext cx="7485185" cy="4351338"/>
-          </a:xfrm>
-        </p:spPr>
-        <p:txBody>
-          <a:bodyPr>
-            <a:normAutofit fontScale="77500" lnSpcReduction="20000"/>
-          </a:bodyPr>
-          <a:lstStyle/>
-          <a:p>
-            <a:r>
-              <a:rPr lang="en-US" dirty="0"/>
-              <a:t>Scrape the XML page for name, </a:t>
-            </a:r>
-            <a:r>
-              <a:rPr lang="en-US" dirty="0" err="1"/>
-              <a:t>zipcode</a:t>
-            </a:r>
-            <a:r>
-              <a:rPr lang="en-US" dirty="0"/>
-              <a:t> and city council district.  (Use either the XML or </a:t>
-            </a:r>
-            <a:r>
-              <a:rPr lang="en-US" dirty="0" err="1"/>
-              <a:t>rvest</a:t>
-            </a:r>
-            <a:r>
-              <a:rPr lang="en-US" dirty="0"/>
-              <a:t> package.)</a:t>
-            </a:r>
-          </a:p>
-          <a:p>
-            <a:r>
-              <a:rPr lang="en-US" dirty="0"/>
-              <a:t>Make a </a:t>
-            </a:r>
-            <a:r>
-              <a:rPr lang="en-US" dirty="0" err="1"/>
-              <a:t>dataframe</a:t>
-            </a:r>
-            <a:r>
-              <a:rPr lang="en-US" dirty="0"/>
-              <a:t> with just those columns.</a:t>
-            </a:r>
-          </a:p>
-          <a:p>
-            <a:r>
-              <a:rPr lang="en-US" dirty="0"/>
-              <a:t>Are there any Sushi restaurants in Baltimore? (Where the dataset is from.)</a:t>
-            </a:r>
-          </a:p>
-          <a:p>
-            <a:r>
-              <a:rPr lang="en-US" dirty="0"/>
-              <a:t>If so, can you estimate how many?</a:t>
-            </a:r>
-          </a:p>
-          <a:p>
-            <a:r>
-              <a:rPr lang="en-US" dirty="0"/>
-              <a:t>Filter the </a:t>
-            </a:r>
-            <a:r>
-              <a:rPr lang="en-US" dirty="0" err="1"/>
-              <a:t>dataframe</a:t>
-            </a:r>
-            <a:r>
-              <a:rPr lang="en-US" dirty="0"/>
-              <a:t> for just downtown restaurants (Council District 11). </a:t>
-            </a:r>
-          </a:p>
-          <a:p>
-            <a:r>
-              <a:rPr lang="en-US" dirty="0"/>
-              <a:t>Are there any Sushi restaurants downtown?  # research the “grep” function</a:t>
-            </a:r>
-          </a:p>
-          <a:p>
-            <a:r>
-              <a:rPr lang="en-US" dirty="0"/>
-              <a:t>If so, estimate how many “Sushi” restaurants are in Downtown</a:t>
-            </a:r>
-          </a:p>
-          <a:p>
-            <a:r>
-              <a:rPr lang="en-US" dirty="0"/>
-              <a:t>Make a </a:t>
-            </a:r>
-            <a:r>
-              <a:rPr lang="en-US" dirty="0" err="1"/>
-              <a:t>barplot</a:t>
-            </a:r>
-            <a:r>
-              <a:rPr lang="en-US" dirty="0"/>
-              <a:t> of the estimated number of restaurants (Sushi or otherwise) in each council.</a:t>
-            </a:r>
-          </a:p>
-        </p:txBody>
-      </p:sp>
+      </p:pic>
     </p:spTree>
     <p:extLst>
       <p:ext uri="{BB962C8B-B14F-4D97-AF65-F5344CB8AC3E}">
-        <p14:creationId xmlns:p14="http://schemas.microsoft.com/office/powerpoint/2010/main" val="909312441"/>
+        <p14:creationId xmlns:p14="http://schemas.microsoft.com/office/powerpoint/2010/main" val="1702773183"/>
       </p:ext>
     </p:extLst>
   </p:cSld>
@@ -3655,7 +4514,7 @@
           <p:cNvPr id="2" name="Title 1">
             <a:extLst>
               <a:ext uri="{FF2B5EF4-FFF2-40B4-BE49-F238E27FC236}">
-                <a16:creationId xmlns:a16="http://schemas.microsoft.com/office/drawing/2014/main" id="{2CD61229-B8D8-2937-2697-CF10755E63C8}"/>
+                <a16:creationId xmlns:a16="http://schemas.microsoft.com/office/drawing/2014/main" id="{296B44D8-066B-233E-9688-78FFF8E9DAB2}"/>
               </a:ext>
             </a:extLst>
           </p:cNvPr>
@@ -3668,63 +4527,60 @@
         </p:nvSpPr>
         <p:spPr/>
         <p:txBody>
-          <a:bodyPr>
-            <a:normAutofit fontScale="90000"/>
-          </a:bodyPr>
+          <a:bodyPr/>
           <a:lstStyle/>
           <a:p>
             <a:r>
               <a:rPr lang="en-US" dirty="0"/>
-              <a:t>Scrape the XML page for name, </a:t>
+              <a:t>Make a </a:t>
             </a:r>
             <a:r>
               <a:rPr lang="en-US" dirty="0" err="1"/>
-              <a:t>zipcode</a:t>
+              <a:t>dataframe</a:t>
             </a:r>
             <a:r>
               <a:rPr lang="en-US" dirty="0"/>
-              <a:t> and city council district.  (Use either the XML or </a:t>
-            </a:r>
-            <a:r>
-              <a:rPr lang="en-US" dirty="0" err="1"/>
-              <a:t>rvest</a:t>
-            </a:r>
-            <a:r>
-              <a:rPr lang="en-US" dirty="0"/>
-              <a:t> package.)</a:t>
-            </a:r>
-          </a:p>
-        </p:txBody>
-      </p:sp>
-      <p:sp>
-        <p:nvSpPr>
-          <p:cNvPr id="5" name="Content Placeholder 4">
-            <a:extLst>
-              <a:ext uri="{FF2B5EF4-FFF2-40B4-BE49-F238E27FC236}">
-                <a16:creationId xmlns:a16="http://schemas.microsoft.com/office/drawing/2014/main" id="{5AEAD8FF-C7C8-37B1-C28C-D7E056AA286D}"/>
-              </a:ext>
-            </a:extLst>
-          </p:cNvPr>
-          <p:cNvSpPr>
-            <a:spLocks noGrp="1"/>
-          </p:cNvSpPr>
+              <a:t> with just those columns.</a:t>
+            </a:r>
+          </a:p>
+        </p:txBody>
+      </p:sp>
+      <p:pic>
+        <p:nvPicPr>
+          <p:cNvPr id="4" name="Content Placeholder 3">
+            <a:extLst>
+              <a:ext uri="{FF2B5EF4-FFF2-40B4-BE49-F238E27FC236}">
+                <a16:creationId xmlns:a16="http://schemas.microsoft.com/office/drawing/2014/main" id="{3F8BCF70-D218-F52C-A119-D6D8C32D491E}"/>
+              </a:ext>
+            </a:extLst>
+          </p:cNvPr>
+          <p:cNvPicPr>
+            <a:picLocks noGrp="1" noChangeAspect="1"/>
+          </p:cNvPicPr>
           <p:nvPr>
             <p:ph idx="1"/>
           </p:nvPr>
-        </p:nvSpPr>
-        <p:spPr/>
-        <p:txBody>
-          <a:bodyPr/>
-          <a:lstStyle/>
-          <a:p>
-            <a:endParaRPr lang="en-US"/>
-          </a:p>
-        </p:txBody>
-      </p:sp>
+        </p:nvPicPr>
+        <p:blipFill>
+          <a:blip r:embed="rId2"/>
+          <a:stretch>
+            <a:fillRect/>
+          </a:stretch>
+        </p:blipFill>
+        <p:spPr>
+          <a:xfrm>
+            <a:off x="2252126" y="2453265"/>
+            <a:ext cx="7687748" cy="3096057"/>
+          </a:xfrm>
+          <a:prstGeom prst="rect">
+            <a:avLst/>
+          </a:prstGeom>
+        </p:spPr>
+      </p:pic>
     </p:spTree>
     <p:extLst>
       <p:ext uri="{BB962C8B-B14F-4D97-AF65-F5344CB8AC3E}">
-        <p14:creationId xmlns:p14="http://schemas.microsoft.com/office/powerpoint/2010/main" val="1702773183"/>
+        <p14:creationId xmlns:p14="http://schemas.microsoft.com/office/powerpoint/2010/main" val="1716946925"/>
       </p:ext>
     </p:extLst>
   </p:cSld>
@@ -3756,7 +4612,7 @@
           <p:cNvPr id="2" name="Title 1">
             <a:extLst>
               <a:ext uri="{FF2B5EF4-FFF2-40B4-BE49-F238E27FC236}">
-                <a16:creationId xmlns:a16="http://schemas.microsoft.com/office/drawing/2014/main" id="{296B44D8-066B-233E-9688-78FFF8E9DAB2}"/>
+                <a16:creationId xmlns:a16="http://schemas.microsoft.com/office/drawing/2014/main" id="{B6520C18-F13C-B47C-8189-BF346C3F979D}"/>
               </a:ext>
             </a:extLst>
           </p:cNvPr>
@@ -3769,53 +4625,97 @@
         </p:nvSpPr>
         <p:spPr/>
         <p:txBody>
-          <a:bodyPr/>
+          <a:bodyPr>
+            <a:normAutofit/>
+          </a:bodyPr>
           <a:lstStyle/>
           <a:p>
             <a:r>
               <a:rPr lang="en-US" dirty="0"/>
-              <a:t>Make a </a:t>
+              <a:t>Are there any Sushi restaurants in Baltimore? (Where the dataset is from.)</a:t>
+            </a:r>
+          </a:p>
+        </p:txBody>
+      </p:sp>
+      <p:pic>
+        <p:nvPicPr>
+          <p:cNvPr id="5" name="Content Placeholder 4">
+            <a:extLst>
+              <a:ext uri="{FF2B5EF4-FFF2-40B4-BE49-F238E27FC236}">
+                <a16:creationId xmlns:a16="http://schemas.microsoft.com/office/drawing/2014/main" id="{9E3BE293-9A5F-DAE9-3EE0-0A27D89AA452}"/>
+              </a:ext>
+            </a:extLst>
+          </p:cNvPr>
+          <p:cNvPicPr>
+            <a:picLocks noGrp="1" noChangeAspect="1"/>
+          </p:cNvPicPr>
+          <p:nvPr>
+            <p:ph idx="1"/>
+          </p:nvPr>
+        </p:nvPicPr>
+        <p:blipFill>
+          <a:blip r:embed="rId2"/>
+          <a:stretch>
+            <a:fillRect/>
+          </a:stretch>
+        </p:blipFill>
+        <p:spPr>
+          <a:xfrm>
+            <a:off x="838200" y="1790471"/>
+            <a:ext cx="5782482" cy="3277057"/>
+          </a:xfrm>
+          <a:prstGeom prst="rect">
+            <a:avLst/>
+          </a:prstGeom>
+        </p:spPr>
+      </p:pic>
+      <p:sp>
+        <p:nvSpPr>
+          <p:cNvPr id="6" name="TextBox 5">
+            <a:extLst>
+              <a:ext uri="{FF2B5EF4-FFF2-40B4-BE49-F238E27FC236}">
+                <a16:creationId xmlns:a16="http://schemas.microsoft.com/office/drawing/2014/main" id="{09F1E500-8C58-2456-E71B-03C97EC94E70}"/>
+              </a:ext>
+            </a:extLst>
+          </p:cNvPr>
+          <p:cNvSpPr txBox="1"/>
+          <p:nvPr/>
+        </p:nvSpPr>
+        <p:spPr>
+          <a:xfrm>
+            <a:off x="7162800" y="2110154"/>
+            <a:ext cx="4044462" cy="1477328"/>
+          </a:xfrm>
+          <a:prstGeom prst="rect">
+            <a:avLst/>
+          </a:prstGeom>
+          <a:noFill/>
+        </p:spPr>
+        <p:txBody>
+          <a:bodyPr wrap="square" rtlCol="0">
+            <a:spAutoFit/>
+          </a:bodyPr>
+          <a:lstStyle/>
+          <a:p>
+            <a:r>
+              <a:rPr lang="en-US" dirty="0"/>
+              <a:t>There are 9 restaurant names in the xml, containing the word “sushi” but searching for “sushi” returns no results. Why does </a:t>
             </a:r>
             <a:r>
               <a:rPr lang="en-US" dirty="0" err="1"/>
-              <a:t>dataframe</a:t>
+              <a:t>ignore.case</a:t>
             </a:r>
             <a:r>
               <a:rPr lang="en-US" dirty="0"/>
-              <a:t> with just those columns.</a:t>
-            </a:r>
-          </a:p>
-        </p:txBody>
-      </p:sp>
-      <p:sp>
-        <p:nvSpPr>
-          <p:cNvPr id="3" name="Content Placeholder 2">
-            <a:extLst>
-              <a:ext uri="{FF2B5EF4-FFF2-40B4-BE49-F238E27FC236}">
-                <a16:creationId xmlns:a16="http://schemas.microsoft.com/office/drawing/2014/main" id="{3209905A-07C7-F2CA-C847-2253EE71E07A}"/>
-              </a:ext>
-            </a:extLst>
-          </p:cNvPr>
-          <p:cNvSpPr>
-            <a:spLocks noGrp="1"/>
-          </p:cNvSpPr>
-          <p:nvPr>
-            <p:ph idx="1"/>
-          </p:nvPr>
-        </p:nvSpPr>
-        <p:spPr/>
-        <p:txBody>
-          <a:bodyPr/>
-          <a:lstStyle/>
-          <a:p>
-            <a:endParaRPr lang="en-US"/>
+              <a:t> not work here?</a:t>
+            </a:r>
           </a:p>
         </p:txBody>
       </p:sp>
     </p:spTree>
     <p:extLst>
       <p:ext uri="{BB962C8B-B14F-4D97-AF65-F5344CB8AC3E}">
-        <p14:creationId xmlns:p14="http://schemas.microsoft.com/office/powerpoint/2010/main" val="1716946925"/>
+        <p14:creationId xmlns:p14="http://schemas.microsoft.com/office/powerpoint/2010/main" val="2308991903"/>
       </p:ext>
     </p:extLst>
   </p:cSld>
@@ -3847,7 +4747,7 @@
           <p:cNvPr id="2" name="Title 1">
             <a:extLst>
               <a:ext uri="{FF2B5EF4-FFF2-40B4-BE49-F238E27FC236}">
-                <a16:creationId xmlns:a16="http://schemas.microsoft.com/office/drawing/2014/main" id="{1FF9FA11-CBBB-8BAE-496B-9C906E1E55F9}"/>
+                <a16:creationId xmlns:a16="http://schemas.microsoft.com/office/drawing/2014/main" id="{B39CBDAC-09C7-F241-4E57-074AE44B8C8C}"/>
               </a:ext>
             </a:extLst>
           </p:cNvPr>
@@ -3860,106 +4760,41 @@
         </p:nvSpPr>
         <p:spPr/>
         <p:txBody>
-          <a:bodyPr/>
+          <a:bodyPr>
+            <a:normAutofit/>
+          </a:bodyPr>
           <a:lstStyle/>
           <a:p>
             <a:r>
               <a:rPr lang="en-US" dirty="0"/>
-              <a:t>Tidy Data</a:t>
-            </a:r>
-          </a:p>
-        </p:txBody>
-      </p:sp>
-      <p:sp>
-        <p:nvSpPr>
-          <p:cNvPr id="3" name="Content Placeholder 2">
-            <a:extLst>
-              <a:ext uri="{FF2B5EF4-FFF2-40B4-BE49-F238E27FC236}">
-                <a16:creationId xmlns:a16="http://schemas.microsoft.com/office/drawing/2014/main" id="{CA8C3866-043F-4D6F-C891-C6B119E9C19C}"/>
-              </a:ext>
-            </a:extLst>
-          </p:cNvPr>
-          <p:cNvSpPr>
-            <a:spLocks noGrp="1"/>
-          </p:cNvSpPr>
-          <p:nvPr>
-            <p:ph idx="1"/>
-          </p:nvPr>
-        </p:nvSpPr>
-        <p:spPr>
-          <a:xfrm>
-            <a:off x="838200" y="1825625"/>
-            <a:ext cx="3991708" cy="3273913"/>
-          </a:xfrm>
-        </p:spPr>
-        <p:txBody>
-          <a:bodyPr>
-            <a:normAutofit fontScale="92500" lnSpcReduction="10000"/>
-          </a:bodyPr>
-          <a:lstStyle/>
-          <a:p>
-            <a:pPr marL="0" indent="0">
-              <a:buNone/>
-            </a:pPr>
+              <a:t>Filter the </a:t>
+            </a:r>
+            <a:r>
+              <a:rPr lang="en-US" dirty="0" err="1"/>
+              <a:t>dataframe</a:t>
+            </a:r>
             <a:r>
               <a:rPr lang="en-US" dirty="0"/>
-              <a:t>“There are three interrelated rules that make a dataset tidy:</a:t>
-            </a:r>
-          </a:p>
-          <a:p>
-            <a:pPr marL="457200" lvl="1" indent="0">
-              <a:buNone/>
-            </a:pPr>
-            <a:r>
-              <a:rPr lang="en-US" dirty="0"/>
-              <a:t>Each variable is a column; each column is a variable.</a:t>
-            </a:r>
-          </a:p>
-          <a:p>
-            <a:pPr marL="457200" lvl="1" indent="0">
-              <a:buNone/>
-            </a:pPr>
-            <a:r>
-              <a:rPr lang="en-US" dirty="0"/>
-              <a:t>Each observation is a row; each row is an observation.</a:t>
-            </a:r>
-          </a:p>
-          <a:p>
-            <a:pPr marL="457200" lvl="1" indent="0">
-              <a:buNone/>
-            </a:pPr>
-            <a:r>
-              <a:rPr lang="en-US" dirty="0"/>
-              <a:t>Each value is a cell; each cell is a single value.”</a:t>
-            </a:r>
-          </a:p>
-          <a:p>
-            <a:pPr marL="457200" lvl="1" indent="0">
-              <a:buNone/>
-            </a:pPr>
-            <a:r>
-              <a:rPr lang="en-US" dirty="0"/>
-              <a:t>(Hadley)</a:t>
-            </a:r>
-          </a:p>
-          <a:p>
-            <a:endParaRPr lang="en-US" dirty="0"/>
+              <a:t> for just downtown restaurants (Council District 11). </a:t>
+            </a:r>
           </a:p>
         </p:txBody>
       </p:sp>
       <p:pic>
         <p:nvPicPr>
-          <p:cNvPr id="5" name="Picture 4">
-            <a:extLst>
-              <a:ext uri="{FF2B5EF4-FFF2-40B4-BE49-F238E27FC236}">
-                <a16:creationId xmlns:a16="http://schemas.microsoft.com/office/drawing/2014/main" id="{53884CE8-772F-A2A7-B16B-DBD648D6CD1E}"/>
+          <p:cNvPr id="5" name="Content Placeholder 4">
+            <a:extLst>
+              <a:ext uri="{FF2B5EF4-FFF2-40B4-BE49-F238E27FC236}">
+                <a16:creationId xmlns:a16="http://schemas.microsoft.com/office/drawing/2014/main" id="{F23ABB78-6493-3F65-8930-401C04B44836}"/>
               </a:ext>
             </a:extLst>
           </p:cNvPr>
           <p:cNvPicPr>
-            <a:picLocks noChangeAspect="1"/>
+            <a:picLocks noGrp="1" noChangeAspect="1"/>
           </p:cNvPicPr>
-          <p:nvPr/>
+          <p:nvPr>
+            <p:ph idx="1"/>
+          </p:nvPr>
         </p:nvPicPr>
         <p:blipFill>
           <a:blip r:embed="rId2"/>
@@ -3969,8 +4804,8 @@
         </p:blipFill>
         <p:spPr>
           <a:xfrm>
-            <a:off x="5430338" y="1141412"/>
-            <a:ext cx="6292250" cy="4575175"/>
+            <a:off x="2054856" y="1825625"/>
+            <a:ext cx="8082287" cy="4351338"/>
           </a:xfrm>
           <a:prstGeom prst="rect">
             <a:avLst/>
@@ -3980,7 +4815,7 @@
     </p:spTree>
     <p:extLst>
       <p:ext uri="{BB962C8B-B14F-4D97-AF65-F5344CB8AC3E}">
-        <p14:creationId xmlns:p14="http://schemas.microsoft.com/office/powerpoint/2010/main" val="4269069606"/>
+        <p14:creationId xmlns:p14="http://schemas.microsoft.com/office/powerpoint/2010/main" val="2485450729"/>
       </p:ext>
     </p:extLst>
   </p:cSld>
@@ -4012,7 +4847,7 @@
           <p:cNvPr id="2" name="Title 1">
             <a:extLst>
               <a:ext uri="{FF2B5EF4-FFF2-40B4-BE49-F238E27FC236}">
-                <a16:creationId xmlns:a16="http://schemas.microsoft.com/office/drawing/2014/main" id="{DE720335-4981-5ED7-8980-9A49CD785CB0}"/>
+                <a16:creationId xmlns:a16="http://schemas.microsoft.com/office/drawing/2014/main" id="{F2DD0905-DF51-09AA-6FFB-B95B7292CD7C}"/>
               </a:ext>
             </a:extLst>
           </p:cNvPr>
@@ -4025,42 +4860,92 @@
         </p:nvSpPr>
         <p:spPr/>
         <p:txBody>
-          <a:bodyPr/>
-          <a:lstStyle/>
-          <a:p>
-            <a:endParaRPr lang="en-US"/>
-          </a:p>
-        </p:txBody>
-      </p:sp>
-      <p:sp>
-        <p:nvSpPr>
-          <p:cNvPr id="3" name="Content Placeholder 2">
-            <a:extLst>
-              <a:ext uri="{FF2B5EF4-FFF2-40B4-BE49-F238E27FC236}">
-                <a16:creationId xmlns:a16="http://schemas.microsoft.com/office/drawing/2014/main" id="{7E423978-AB89-8F4F-CD99-6A49AB3477A8}"/>
-              </a:ext>
-            </a:extLst>
-          </p:cNvPr>
-          <p:cNvSpPr>
-            <a:spLocks noGrp="1"/>
-          </p:cNvSpPr>
+          <a:bodyPr>
+            <a:normAutofit fontScale="90000"/>
+          </a:bodyPr>
+          <a:lstStyle/>
+          <a:p>
+            <a:r>
+              <a:rPr lang="en-US" dirty="0"/>
+              <a:t>Make a </a:t>
+            </a:r>
+            <a:r>
+              <a:rPr lang="en-US" dirty="0" err="1"/>
+              <a:t>barplot</a:t>
+            </a:r>
+            <a:r>
+              <a:rPr lang="en-US" dirty="0"/>
+              <a:t> of the estimated number of restaurants (Sushi or otherwise) in each council.</a:t>
+            </a:r>
+          </a:p>
+        </p:txBody>
+      </p:sp>
+      <p:pic>
+        <p:nvPicPr>
+          <p:cNvPr id="9" name="Content Placeholder 8">
+            <a:extLst>
+              <a:ext uri="{FF2B5EF4-FFF2-40B4-BE49-F238E27FC236}">
+                <a16:creationId xmlns:a16="http://schemas.microsoft.com/office/drawing/2014/main" id="{1D9D0D18-3837-4AB1-053B-A5FE06604250}"/>
+              </a:ext>
+            </a:extLst>
+          </p:cNvPr>
+          <p:cNvPicPr>
+            <a:picLocks noGrp="1" noChangeAspect="1"/>
+          </p:cNvPicPr>
           <p:nvPr>
             <p:ph idx="1"/>
           </p:nvPr>
-        </p:nvSpPr>
-        <p:spPr/>
-        <p:txBody>
-          <a:bodyPr/>
-          <a:lstStyle/>
-          <a:p>
-            <a:endParaRPr lang="en-US" dirty="0"/>
-          </a:p>
-        </p:txBody>
-      </p:sp>
+        </p:nvPicPr>
+        <p:blipFill>
+          <a:blip r:embed="rId2"/>
+          <a:stretch>
+            <a:fillRect/>
+          </a:stretch>
+        </p:blipFill>
+        <p:spPr>
+          <a:xfrm>
+            <a:off x="279073" y="2551432"/>
+            <a:ext cx="6930619" cy="3206035"/>
+          </a:xfrm>
+          <a:prstGeom prst="rect">
+            <a:avLst/>
+          </a:prstGeom>
+        </p:spPr>
+      </p:pic>
+      <p:pic>
+        <p:nvPicPr>
+          <p:cNvPr id="11" name="Picture 10">
+            <a:extLst>
+              <a:ext uri="{FF2B5EF4-FFF2-40B4-BE49-F238E27FC236}">
+                <a16:creationId xmlns:a16="http://schemas.microsoft.com/office/drawing/2014/main" id="{81931F9D-AF93-050F-57BB-0E9C0B9F1BE6}"/>
+              </a:ext>
+            </a:extLst>
+          </p:cNvPr>
+          <p:cNvPicPr>
+            <a:picLocks noChangeAspect="1"/>
+          </p:cNvPicPr>
+          <p:nvPr/>
+        </p:nvPicPr>
+        <p:blipFill>
+          <a:blip r:embed="rId3"/>
+          <a:stretch>
+            <a:fillRect/>
+          </a:stretch>
+        </p:blipFill>
+        <p:spPr>
+          <a:xfrm>
+            <a:off x="7039542" y="2236900"/>
+            <a:ext cx="5152458" cy="3637329"/>
+          </a:xfrm>
+          <a:prstGeom prst="rect">
+            <a:avLst/>
+          </a:prstGeom>
+        </p:spPr>
+      </p:pic>
     </p:spTree>
     <p:extLst>
       <p:ext uri="{BB962C8B-B14F-4D97-AF65-F5344CB8AC3E}">
-        <p14:creationId xmlns:p14="http://schemas.microsoft.com/office/powerpoint/2010/main" val="3969572359"/>
+        <p14:creationId xmlns:p14="http://schemas.microsoft.com/office/powerpoint/2010/main" val="193343768"/>
       </p:ext>
     </p:extLst>
   </p:cSld>
@@ -4087,48 +4972,12 @@
           <a:chExt cx="0" cy="0"/>
         </a:xfrm>
       </p:grpSpPr>
-      <p:sp>
-        <p:nvSpPr>
-          <p:cNvPr id="2" name="Title 1">
-            <a:extLst>
-              <a:ext uri="{FF2B5EF4-FFF2-40B4-BE49-F238E27FC236}">
-                <a16:creationId xmlns:a16="http://schemas.microsoft.com/office/drawing/2014/main" id="{E6C61B9D-C38C-4BAE-AB2A-D4A6B91E069E}"/>
-              </a:ext>
-            </a:extLst>
-          </p:cNvPr>
-          <p:cNvSpPr>
-            <a:spLocks noGrp="1"/>
-          </p:cNvSpPr>
-          <p:nvPr>
-            <p:ph type="title"/>
-          </p:nvPr>
-        </p:nvSpPr>
-        <p:spPr/>
-        <p:txBody>
-          <a:bodyPr/>
-          <a:lstStyle/>
-          <a:p>
-            <a:r>
-              <a:rPr lang="en-US" dirty="0"/>
-              <a:t>NASA SBDB (Small-Body </a:t>
-            </a:r>
-            <a:r>
-              <a:rPr lang="en-US" dirty="0" err="1"/>
-              <a:t>DataBase</a:t>
-            </a:r>
-            <a:r>
-              <a:rPr lang="en-US" dirty="0"/>
-              <a:t>) API</a:t>
-            </a:r>
-          </a:p>
-        </p:txBody>
-      </p:sp>
       <p:pic>
         <p:nvPicPr>
-          <p:cNvPr id="5" name="Content Placeholder 4">
-            <a:extLst>
-              <a:ext uri="{FF2B5EF4-FFF2-40B4-BE49-F238E27FC236}">
-                <a16:creationId xmlns:a16="http://schemas.microsoft.com/office/drawing/2014/main" id="{CA7A3BB6-8361-0ADC-69F9-AC4B73A1899B}"/>
+          <p:cNvPr id="7" name="Content Placeholder 6">
+            <a:extLst>
+              <a:ext uri="{FF2B5EF4-FFF2-40B4-BE49-F238E27FC236}">
+                <a16:creationId xmlns:a16="http://schemas.microsoft.com/office/drawing/2014/main" id="{5F6B59B4-E476-7C47-F113-DAC3D6328832}"/>
               </a:ext>
             </a:extLst>
           </p:cNvPr>
@@ -4147,8 +4996,1293 @@
         </p:blipFill>
         <p:spPr>
           <a:xfrm>
-            <a:off x="3028522" y="2353239"/>
-            <a:ext cx="6134956" cy="3296110"/>
+            <a:off x="483789" y="414844"/>
+            <a:ext cx="8909594" cy="4933318"/>
+          </a:xfrm>
+          <a:prstGeom prst="rect">
+            <a:avLst/>
+          </a:prstGeom>
+        </p:spPr>
+      </p:pic>
+      <p:sp>
+        <p:nvSpPr>
+          <p:cNvPr id="8" name="TextBox 7">
+            <a:extLst>
+              <a:ext uri="{FF2B5EF4-FFF2-40B4-BE49-F238E27FC236}">
+                <a16:creationId xmlns:a16="http://schemas.microsoft.com/office/drawing/2014/main" id="{58EE6B25-873B-407F-81E2-CCC28877BB6F}"/>
+              </a:ext>
+            </a:extLst>
+          </p:cNvPr>
+          <p:cNvSpPr txBox="1"/>
+          <p:nvPr/>
+        </p:nvSpPr>
+        <p:spPr>
+          <a:xfrm>
+            <a:off x="3424052" y="5682343"/>
+            <a:ext cx="5343896" cy="369332"/>
+          </a:xfrm>
+          <a:prstGeom prst="rect">
+            <a:avLst/>
+          </a:prstGeom>
+          <a:noFill/>
+        </p:spPr>
+        <p:txBody>
+          <a:bodyPr wrap="square" rtlCol="0">
+            <a:spAutoFit/>
+          </a:bodyPr>
+          <a:lstStyle/>
+          <a:p>
+            <a:r>
+              <a:rPr lang="en-US" dirty="0">
+                <a:hlinkClick r:id="rId3"/>
+              </a:rPr>
+              <a:t>https://ssd-api.jpl.nasa.gov/doc/sbdb_query.html</a:t>
+            </a:r>
+            <a:endParaRPr lang="en-US" dirty="0"/>
+          </a:p>
+        </p:txBody>
+      </p:sp>
+    </p:spTree>
+    <p:extLst>
+      <p:ext uri="{BB962C8B-B14F-4D97-AF65-F5344CB8AC3E}">
+        <p14:creationId xmlns:p14="http://schemas.microsoft.com/office/powerpoint/2010/main" val="1613486004"/>
+      </p:ext>
+    </p:extLst>
+  </p:cSld>
+  <p:clrMapOvr>
+    <a:masterClrMapping/>
+  </p:clrMapOvr>
+</p:sld>
+</file>
+
+<file path=ppt/slides/slide8.xml><?xml version="1.0" encoding="utf-8"?>
+<p:sld xmlns:a="http://schemas.openxmlformats.org/drawingml/2006/main" xmlns:r="http://schemas.openxmlformats.org/officeDocument/2006/relationships" xmlns:p="http://schemas.openxmlformats.org/presentationml/2006/main">
+  <p:cSld>
+    <p:spTree>
+      <p:nvGrpSpPr>
+        <p:cNvPr id="1" name=""/>
+        <p:cNvGrpSpPr/>
+        <p:nvPr/>
+      </p:nvGrpSpPr>
+      <p:grpSpPr>
+        <a:xfrm>
+          <a:off x="0" y="0"/>
+          <a:ext cx="0" cy="0"/>
+          <a:chOff x="0" y="0"/>
+          <a:chExt cx="0" cy="0"/>
+        </a:xfrm>
+      </p:grpSpPr>
+      <p:sp>
+        <p:nvSpPr>
+          <p:cNvPr id="2" name="Title 1">
+            <a:extLst>
+              <a:ext uri="{FF2B5EF4-FFF2-40B4-BE49-F238E27FC236}">
+                <a16:creationId xmlns:a16="http://schemas.microsoft.com/office/drawing/2014/main" id="{DE720335-4981-5ED7-8980-9A49CD785CB0}"/>
+              </a:ext>
+            </a:extLst>
+          </p:cNvPr>
+          <p:cNvSpPr>
+            <a:spLocks noGrp="1"/>
+          </p:cNvSpPr>
+          <p:nvPr>
+            <p:ph type="title"/>
+          </p:nvPr>
+        </p:nvSpPr>
+        <p:spPr/>
+        <p:txBody>
+          <a:bodyPr>
+            <a:normAutofit fontScale="90000"/>
+          </a:bodyPr>
+          <a:lstStyle/>
+          <a:p>
+            <a:r>
+              <a:rPr lang="en-US" dirty="0"/>
+              <a:t>Clearly describe the data and the columns / variables that are of interest to your presentation.</a:t>
+            </a:r>
+          </a:p>
+        </p:txBody>
+      </p:sp>
+      <p:graphicFrame>
+        <p:nvGraphicFramePr>
+          <p:cNvPr id="12" name="Table 11">
+            <a:extLst>
+              <a:ext uri="{FF2B5EF4-FFF2-40B4-BE49-F238E27FC236}">
+                <a16:creationId xmlns:a16="http://schemas.microsoft.com/office/drawing/2014/main" id="{3EB5BB67-88EA-2582-00D2-050907897F11}"/>
+              </a:ext>
+            </a:extLst>
+          </p:cNvPr>
+          <p:cNvGraphicFramePr>
+            <a:graphicFrameLocks noGrp="1"/>
+          </p:cNvGraphicFramePr>
+          <p:nvPr>
+            <p:extLst>
+              <p:ext uri="{D42A27DB-BD31-4B8C-83A1-F6EECF244321}">
+                <p14:modId xmlns:p14="http://schemas.microsoft.com/office/powerpoint/2010/main" val="2202203152"/>
+              </p:ext>
+            </p:extLst>
+          </p:nvPr>
+        </p:nvGraphicFramePr>
+        <p:xfrm>
+          <a:off x="651493" y="1871642"/>
+          <a:ext cx="10515600" cy="3984336"/>
+        </p:xfrm>
+        <a:graphic>
+          <a:graphicData uri="http://schemas.openxmlformats.org/drawingml/2006/table">
+            <a:tbl>
+              <a:tblPr>
+                <a:tableStyleId>{5C22544A-7EE6-4342-B048-85BDC9FD1C3A}</a:tableStyleId>
+              </a:tblPr>
+              <a:tblGrid>
+                <a:gridCol w="1169929">
+                  <a:extLst>
+                    <a:ext uri="{9D8B030D-6E8A-4147-A177-3AD203B41FA5}">
+                      <a16:colId xmlns:a16="http://schemas.microsoft.com/office/drawing/2014/main" val="2331060784"/>
+                    </a:ext>
+                  </a:extLst>
+                </a:gridCol>
+                <a:gridCol w="757013">
+                  <a:extLst>
+                    <a:ext uri="{9D8B030D-6E8A-4147-A177-3AD203B41FA5}">
+                      <a16:colId xmlns:a16="http://schemas.microsoft.com/office/drawing/2014/main" val="2237770712"/>
+                    </a:ext>
+                  </a:extLst>
+                </a:gridCol>
+                <a:gridCol w="2862886">
+                  <a:extLst>
+                    <a:ext uri="{9D8B030D-6E8A-4147-A177-3AD203B41FA5}">
+                      <a16:colId xmlns:a16="http://schemas.microsoft.com/office/drawing/2014/main" val="924880989"/>
+                    </a:ext>
+                  </a:extLst>
+                </a:gridCol>
+                <a:gridCol w="4676456">
+                  <a:extLst>
+                    <a:ext uri="{9D8B030D-6E8A-4147-A177-3AD203B41FA5}">
+                      <a16:colId xmlns:a16="http://schemas.microsoft.com/office/drawing/2014/main" val="3040211411"/>
+                    </a:ext>
+                  </a:extLst>
+                </a:gridCol>
+                <a:gridCol w="1049316">
+                  <a:extLst>
+                    <a:ext uri="{9D8B030D-6E8A-4147-A177-3AD203B41FA5}">
+                      <a16:colId xmlns:a16="http://schemas.microsoft.com/office/drawing/2014/main" val="3514468263"/>
+                    </a:ext>
+                  </a:extLst>
+                </a:gridCol>
+              </a:tblGrid>
+              <a:tr h="230217">
+                <a:tc>
+                  <a:txBody>
+                    <a:bodyPr/>
+                    <a:lstStyle/>
+                    <a:p>
+                      <a:pPr algn="l" rtl="0" fontAlgn="ctr">
+                        <a:buNone/>
+                      </a:pPr>
+                      <a:r>
+                        <a:rPr lang="en-US" sz="1400" u="none" strike="noStrike">
+                          <a:effectLst/>
+                        </a:rPr>
+                        <a:t>Field Name</a:t>
+                      </a:r>
+                      <a:endParaRPr lang="en-US" sz="1400" b="0" i="0" u="none" strike="noStrike">
+                        <a:solidFill>
+                          <a:srgbClr val="000000"/>
+                        </a:solidFill>
+                        <a:effectLst/>
+                        <a:latin typeface="Aptos" panose="020B0004020202020204" pitchFamily="34" charset="0"/>
+                      </a:endParaRPr>
+                    </a:p>
+                  </a:txBody>
+                  <a:tcPr marL="6633" marR="6633" marT="6633" marB="0" anchor="ctr"/>
+                </a:tc>
+                <a:tc>
+                  <a:txBody>
+                    <a:bodyPr/>
+                    <a:lstStyle/>
+                    <a:p>
+                      <a:pPr algn="ctr" rtl="0" fontAlgn="ctr">
+                        <a:buNone/>
+                      </a:pPr>
+                      <a:r>
+                        <a:rPr lang="en-US" sz="1400" u="none" strike="noStrike">
+                          <a:effectLst/>
+                        </a:rPr>
+                        <a:t>Type</a:t>
+                      </a:r>
+                      <a:endParaRPr lang="en-US" sz="1400" b="0" i="0" u="none" strike="noStrike">
+                        <a:solidFill>
+                          <a:srgbClr val="000000"/>
+                        </a:solidFill>
+                        <a:effectLst/>
+                        <a:latin typeface="Aptos" panose="020B0004020202020204" pitchFamily="34" charset="0"/>
+                      </a:endParaRPr>
+                    </a:p>
+                  </a:txBody>
+                  <a:tcPr marL="6633" marR="6633" marT="6633" marB="0" anchor="ctr"/>
+                </a:tc>
+                <a:tc>
+                  <a:txBody>
+                    <a:bodyPr/>
+                    <a:lstStyle/>
+                    <a:p>
+                      <a:pPr algn="l" rtl="0" fontAlgn="ctr">
+                        <a:buNone/>
+                      </a:pPr>
+                      <a:r>
+                        <a:rPr lang="en-US" sz="1400" u="none" strike="noStrike">
+                          <a:effectLst/>
+                        </a:rPr>
+                        <a:t>Description</a:t>
+                      </a:r>
+                      <a:endParaRPr lang="en-US" sz="1400" b="0" i="0" u="none" strike="noStrike">
+                        <a:solidFill>
+                          <a:srgbClr val="000000"/>
+                        </a:solidFill>
+                        <a:effectLst/>
+                        <a:latin typeface="Aptos" panose="020B0004020202020204" pitchFamily="34" charset="0"/>
+                      </a:endParaRPr>
+                    </a:p>
+                  </a:txBody>
+                  <a:tcPr marL="6633" marR="6633" marT="6633" marB="0" anchor="ctr"/>
+                </a:tc>
+                <a:tc>
+                  <a:txBody>
+                    <a:bodyPr/>
+                    <a:lstStyle/>
+                    <a:p>
+                      <a:pPr algn="l" rtl="0" fontAlgn="ctr">
+                        <a:buNone/>
+                      </a:pPr>
+                      <a:r>
+                        <a:rPr lang="en-US" sz="1400" u="none" strike="noStrike">
+                          <a:effectLst/>
+                        </a:rPr>
+                        <a:t>Meaning</a:t>
+                      </a:r>
+                      <a:endParaRPr lang="en-US" sz="1400" b="0" i="0" u="none" strike="noStrike">
+                        <a:solidFill>
+                          <a:srgbClr val="000000"/>
+                        </a:solidFill>
+                        <a:effectLst/>
+                        <a:latin typeface="Aptos" panose="020B0004020202020204" pitchFamily="34" charset="0"/>
+                      </a:endParaRPr>
+                    </a:p>
+                  </a:txBody>
+                  <a:tcPr marL="6633" marR="6633" marT="6633" marB="0" anchor="ctr"/>
+                </a:tc>
+                <a:tc>
+                  <a:txBody>
+                    <a:bodyPr/>
+                    <a:lstStyle/>
+                    <a:p>
+                      <a:pPr algn="l" rtl="0" fontAlgn="ctr">
+                        <a:buNone/>
+                      </a:pPr>
+                      <a:r>
+                        <a:rPr lang="en-US" sz="1400" u="none" strike="noStrike">
+                          <a:effectLst/>
+                        </a:rPr>
+                        <a:t>Example</a:t>
+                      </a:r>
+                      <a:endParaRPr lang="en-US" sz="1400" b="0" i="0" u="none" strike="noStrike">
+                        <a:solidFill>
+                          <a:srgbClr val="000000"/>
+                        </a:solidFill>
+                        <a:effectLst/>
+                        <a:latin typeface="Aptos" panose="020B0004020202020204" pitchFamily="34" charset="0"/>
+                      </a:endParaRPr>
+                    </a:p>
+                  </a:txBody>
+                  <a:tcPr marL="6633" marR="6633" marT="6633" marB="0" anchor="ctr"/>
+                </a:tc>
+                <a:extLst>
+                  <a:ext uri="{0D108BD9-81ED-4DB2-BD59-A6C34878D82A}">
+                    <a16:rowId xmlns:a16="http://schemas.microsoft.com/office/drawing/2014/main" val="1785214912"/>
+                  </a:ext>
+                </a:extLst>
+              </a:tr>
+              <a:tr h="724410">
+                <a:tc>
+                  <a:txBody>
+                    <a:bodyPr/>
+                    <a:lstStyle/>
+                    <a:p>
+                      <a:pPr algn="l" rtl="0" fontAlgn="ctr">
+                        <a:buNone/>
+                      </a:pPr>
+                      <a:r>
+                        <a:rPr lang="en-US" sz="1400" u="none" strike="noStrike">
+                          <a:effectLst/>
+                        </a:rPr>
+                        <a:t>rms</a:t>
+                      </a:r>
+                      <a:endParaRPr lang="en-US" sz="1400" b="0" i="0" u="none" strike="noStrike">
+                        <a:solidFill>
+                          <a:srgbClr val="000000"/>
+                        </a:solidFill>
+                        <a:effectLst/>
+                        <a:latin typeface="Aptos" panose="020B0004020202020204" pitchFamily="34" charset="0"/>
+                      </a:endParaRPr>
+                    </a:p>
+                  </a:txBody>
+                  <a:tcPr marL="6633" marR="6633" marT="6633" marB="0" anchor="ctr"/>
+                </a:tc>
+                <a:tc>
+                  <a:txBody>
+                    <a:bodyPr/>
+                    <a:lstStyle/>
+                    <a:p>
+                      <a:pPr algn="ctr" rtl="0" fontAlgn="ctr">
+                        <a:buNone/>
+                      </a:pPr>
+                      <a:r>
+                        <a:rPr lang="en-US" sz="1400" u="none" strike="noStrike">
+                          <a:effectLst/>
+                        </a:rPr>
+                        <a:t>number</a:t>
+                      </a:r>
+                      <a:endParaRPr lang="en-US" sz="1400" b="0" i="0" u="none" strike="noStrike">
+                        <a:solidFill>
+                          <a:srgbClr val="000000"/>
+                        </a:solidFill>
+                        <a:effectLst/>
+                        <a:latin typeface="Aptos" panose="020B0004020202020204" pitchFamily="34" charset="0"/>
+                      </a:endParaRPr>
+                    </a:p>
+                  </a:txBody>
+                  <a:tcPr marL="6633" marR="6633" marT="6633" marB="0" anchor="ctr"/>
+                </a:tc>
+                <a:tc>
+                  <a:txBody>
+                    <a:bodyPr/>
+                    <a:lstStyle/>
+                    <a:p>
+                      <a:pPr algn="l" rtl="0" fontAlgn="ctr">
+                        <a:buNone/>
+                      </a:pPr>
+                      <a:r>
+                        <a:rPr lang="en-US" sz="1400" u="none" strike="noStrike" dirty="0">
+                          <a:effectLst/>
+                        </a:rPr>
+                        <a:t>normalized RMS of the observation fit in the OD</a:t>
+                      </a:r>
+                      <a:endParaRPr lang="en-US" sz="1400" b="0" i="0" u="none" strike="noStrike" dirty="0">
+                        <a:solidFill>
+                          <a:srgbClr val="000000"/>
+                        </a:solidFill>
+                        <a:effectLst/>
+                        <a:latin typeface="Aptos" panose="020B0004020202020204" pitchFamily="34" charset="0"/>
+                      </a:endParaRPr>
+                    </a:p>
+                  </a:txBody>
+                  <a:tcPr marL="6633" marR="6633" marT="6633" marB="0" anchor="ctr"/>
+                </a:tc>
+                <a:tc>
+                  <a:txBody>
+                    <a:bodyPr/>
+                    <a:lstStyle/>
+                    <a:p>
+                      <a:pPr algn="l" rtl="0" fontAlgn="ctr">
+                        <a:buNone/>
+                      </a:pPr>
+                      <a:r>
+                        <a:rPr lang="en-US" sz="1400" u="none" strike="noStrike">
+                          <a:effectLst/>
+                        </a:rPr>
+                        <a:t>The RMS of the orbit of a small body measures how well the computed orbit fits the observational data.Lower RMS values indicate a better orbit fit.</a:t>
+                      </a:r>
+                      <a:endParaRPr lang="en-US" sz="1400" b="0" i="0" u="none" strike="noStrike">
+                        <a:solidFill>
+                          <a:srgbClr val="000000"/>
+                        </a:solidFill>
+                        <a:effectLst/>
+                        <a:latin typeface="Aptos" panose="020B0004020202020204" pitchFamily="34" charset="0"/>
+                      </a:endParaRPr>
+                    </a:p>
+                  </a:txBody>
+                  <a:tcPr marL="6633" marR="6633" marT="6633" marB="0" anchor="ctr"/>
+                </a:tc>
+                <a:tc>
+                  <a:txBody>
+                    <a:bodyPr/>
+                    <a:lstStyle/>
+                    <a:p>
+                      <a:pPr algn="r" rtl="0" fontAlgn="ctr">
+                        <a:buNone/>
+                      </a:pPr>
+                      <a:r>
+                        <a:rPr lang="en-US" sz="1400" u="none" strike="noStrike">
+                          <a:effectLst/>
+                        </a:rPr>
+                        <a:t>0.43382</a:t>
+                      </a:r>
+                      <a:endParaRPr lang="en-US" sz="1400" b="0" i="0" u="none" strike="noStrike">
+                        <a:solidFill>
+                          <a:srgbClr val="000000"/>
+                        </a:solidFill>
+                        <a:effectLst/>
+                        <a:latin typeface="Aptos" panose="020B0004020202020204" pitchFamily="34" charset="0"/>
+                      </a:endParaRPr>
+                    </a:p>
+                  </a:txBody>
+                  <a:tcPr marL="6633" marR="6633" marT="6633" marB="0" anchor="ctr"/>
+                </a:tc>
+                <a:extLst>
+                  <a:ext uri="{0D108BD9-81ED-4DB2-BD59-A6C34878D82A}">
+                    <a16:rowId xmlns:a16="http://schemas.microsoft.com/office/drawing/2014/main" val="2840219470"/>
+                  </a:ext>
+                </a:extLst>
+              </a:tr>
+              <a:tr h="580677">
+                <a:tc>
+                  <a:txBody>
+                    <a:bodyPr/>
+                    <a:lstStyle/>
+                    <a:p>
+                      <a:pPr algn="l" rtl="0" fontAlgn="ctr">
+                        <a:buNone/>
+                      </a:pPr>
+                      <a:r>
+                        <a:rPr lang="en-US" sz="1400" u="none" strike="noStrike" dirty="0" err="1">
+                          <a:effectLst/>
+                        </a:rPr>
+                        <a:t>last_obs</a:t>
+                      </a:r>
+                      <a:endParaRPr lang="en-US" sz="1400" b="0" i="0" u="none" strike="noStrike" dirty="0">
+                        <a:solidFill>
+                          <a:srgbClr val="000000"/>
+                        </a:solidFill>
+                        <a:effectLst/>
+                        <a:latin typeface="Aptos" panose="020B0004020202020204" pitchFamily="34" charset="0"/>
+                      </a:endParaRPr>
+                    </a:p>
+                  </a:txBody>
+                  <a:tcPr marL="6633" marR="6633" marT="6633" marB="0" anchor="ctr"/>
+                </a:tc>
+                <a:tc>
+                  <a:txBody>
+                    <a:bodyPr/>
+                    <a:lstStyle/>
+                    <a:p>
+                      <a:pPr algn="ctr" rtl="0" fontAlgn="ctr">
+                        <a:buNone/>
+                      </a:pPr>
+                      <a:r>
+                        <a:rPr lang="en-US" sz="1400" u="none" strike="noStrike">
+                          <a:effectLst/>
+                        </a:rPr>
+                        <a:t>string</a:t>
+                      </a:r>
+                      <a:endParaRPr lang="en-US" sz="1400" b="0" i="0" u="none" strike="noStrike">
+                        <a:solidFill>
+                          <a:srgbClr val="000000"/>
+                        </a:solidFill>
+                        <a:effectLst/>
+                        <a:latin typeface="Aptos" panose="020B0004020202020204" pitchFamily="34" charset="0"/>
+                      </a:endParaRPr>
+                    </a:p>
+                  </a:txBody>
+                  <a:tcPr marL="6633" marR="6633" marT="6633" marB="0" anchor="ctr"/>
+                </a:tc>
+                <a:tc>
+                  <a:txBody>
+                    <a:bodyPr/>
+                    <a:lstStyle/>
+                    <a:p>
+                      <a:pPr algn="l" rtl="0" fontAlgn="ctr">
+                        <a:buNone/>
+                      </a:pPr>
+                      <a:r>
+                        <a:rPr lang="en-US" sz="1400" u="none" strike="noStrike" dirty="0">
+                          <a:effectLst/>
+                        </a:rPr>
+                        <a:t>date of the last observation used in the orbit (YYYY-MM-DD or YYYY-??-?? when only the year is known)</a:t>
+                      </a:r>
+                      <a:endParaRPr lang="en-US" sz="1400" b="0" i="0" u="none" strike="noStrike" dirty="0">
+                        <a:solidFill>
+                          <a:srgbClr val="000000"/>
+                        </a:solidFill>
+                        <a:effectLst/>
+                        <a:latin typeface="Aptos" panose="020B0004020202020204" pitchFamily="34" charset="0"/>
+                      </a:endParaRPr>
+                    </a:p>
+                  </a:txBody>
+                  <a:tcPr marL="6633" marR="6633" marT="6633" marB="0" anchor="ctr"/>
+                </a:tc>
+                <a:tc>
+                  <a:txBody>
+                    <a:bodyPr/>
+                    <a:lstStyle/>
+                    <a:p>
+                      <a:pPr algn="l" rtl="0" fontAlgn="ctr">
+                        <a:buNone/>
+                      </a:pPr>
+                      <a:r>
+                        <a:rPr lang="en-US" sz="1400" u="none" strike="noStrike">
+                          <a:effectLst/>
+                        </a:rPr>
+                        <a:t>For calculating the orbit prediction, when was the last time it was updated with data from an observed orbit?</a:t>
+                      </a:r>
+                      <a:endParaRPr lang="en-US" sz="1400" b="0" i="0" u="none" strike="noStrike">
+                        <a:solidFill>
+                          <a:srgbClr val="000000"/>
+                        </a:solidFill>
+                        <a:effectLst/>
+                        <a:latin typeface="Aptos" panose="020B0004020202020204" pitchFamily="34" charset="0"/>
+                      </a:endParaRPr>
+                    </a:p>
+                  </a:txBody>
+                  <a:tcPr marL="6633" marR="6633" marT="6633" marB="0" anchor="ctr"/>
+                </a:tc>
+                <a:tc>
+                  <a:txBody>
+                    <a:bodyPr/>
+                    <a:lstStyle/>
+                    <a:p>
+                      <a:pPr algn="r" rtl="0" fontAlgn="ctr">
+                        <a:buNone/>
+                      </a:pPr>
+                      <a:r>
+                        <a:rPr lang="en-US" sz="1400" u="none" strike="noStrike" dirty="0">
+                          <a:effectLst/>
+                        </a:rPr>
+                        <a:t>11/7/2025</a:t>
+                      </a:r>
+                      <a:endParaRPr lang="en-US" sz="1400" b="0" i="0" u="none" strike="noStrike" dirty="0">
+                        <a:solidFill>
+                          <a:srgbClr val="000000"/>
+                        </a:solidFill>
+                        <a:effectLst/>
+                        <a:latin typeface="Aptos" panose="020B0004020202020204" pitchFamily="34" charset="0"/>
+                      </a:endParaRPr>
+                    </a:p>
+                  </a:txBody>
+                  <a:tcPr marL="6633" marR="6633" marT="6633" marB="0" anchor="ctr"/>
+                </a:tc>
+                <a:extLst>
+                  <a:ext uri="{0D108BD9-81ED-4DB2-BD59-A6C34878D82A}">
+                    <a16:rowId xmlns:a16="http://schemas.microsoft.com/office/drawing/2014/main" val="192741010"/>
+                  </a:ext>
+                </a:extLst>
+              </a:tr>
+              <a:tr h="1155606">
+                <a:tc>
+                  <a:txBody>
+                    <a:bodyPr/>
+                    <a:lstStyle/>
+                    <a:p>
+                      <a:pPr algn="l" rtl="0" fontAlgn="ctr">
+                        <a:buNone/>
+                      </a:pPr>
+                      <a:r>
+                        <a:rPr lang="en-US" sz="1400" u="none" strike="noStrike">
+                          <a:effectLst/>
+                        </a:rPr>
+                        <a:t>spkid</a:t>
+                      </a:r>
+                      <a:endParaRPr lang="en-US" sz="1400" b="0" i="0" u="none" strike="noStrike">
+                        <a:solidFill>
+                          <a:srgbClr val="000000"/>
+                        </a:solidFill>
+                        <a:effectLst/>
+                        <a:latin typeface="Aptos" panose="020B0004020202020204" pitchFamily="34" charset="0"/>
+                      </a:endParaRPr>
+                    </a:p>
+                  </a:txBody>
+                  <a:tcPr marL="6633" marR="6633" marT="6633" marB="0" anchor="ctr"/>
+                </a:tc>
+                <a:tc>
+                  <a:txBody>
+                    <a:bodyPr/>
+                    <a:lstStyle/>
+                    <a:p>
+                      <a:pPr algn="ctr" rtl="0" fontAlgn="ctr">
+                        <a:buNone/>
+                      </a:pPr>
+                      <a:r>
+                        <a:rPr lang="en-US" sz="1400" u="none" strike="noStrike">
+                          <a:effectLst/>
+                        </a:rPr>
+                        <a:t>string</a:t>
+                      </a:r>
+                      <a:endParaRPr lang="en-US" sz="1400" b="0" i="0" u="none" strike="noStrike">
+                        <a:solidFill>
+                          <a:srgbClr val="000000"/>
+                        </a:solidFill>
+                        <a:effectLst/>
+                        <a:latin typeface="Aptos" panose="020B0004020202020204" pitchFamily="34" charset="0"/>
+                      </a:endParaRPr>
+                    </a:p>
+                  </a:txBody>
+                  <a:tcPr marL="6633" marR="6633" marT="6633" marB="0" anchor="ctr"/>
+                </a:tc>
+                <a:tc>
+                  <a:txBody>
+                    <a:bodyPr/>
+                    <a:lstStyle/>
+                    <a:p>
+                      <a:pPr algn="l" rtl="0" fontAlgn="ctr">
+                        <a:buNone/>
+                      </a:pPr>
+                      <a:r>
+                        <a:rPr lang="en-US" sz="1400" u="none" strike="noStrike">
+                          <a:effectLst/>
+                        </a:rPr>
+                        <a:t>primary SPK-ID</a:t>
+                      </a:r>
+                      <a:endParaRPr lang="en-US" sz="1400" b="0" i="0" u="none" strike="noStrike">
+                        <a:solidFill>
+                          <a:srgbClr val="000000"/>
+                        </a:solidFill>
+                        <a:effectLst/>
+                        <a:latin typeface="Aptos" panose="020B0004020202020204" pitchFamily="34" charset="0"/>
+                      </a:endParaRPr>
+                    </a:p>
+                  </a:txBody>
+                  <a:tcPr marL="6633" marR="6633" marT="6633" marB="0" anchor="ctr"/>
+                </a:tc>
+                <a:tc>
+                  <a:txBody>
+                    <a:bodyPr/>
+                    <a:lstStyle/>
+                    <a:p>
+                      <a:pPr algn="l" rtl="0" fontAlgn="ctr">
+                        <a:buNone/>
+                      </a:pPr>
+                      <a:r>
+                        <a:rPr lang="en-US" sz="1400" u="none" strike="noStrike">
+                          <a:effectLst/>
+                        </a:rPr>
+                        <a:t>An SPK ID (Spacecraft and Planet Kernel Identification number) is a unique integer code assigned by NASA to identify specific solar system bodies, spacecraft, or instruments within the SPICE system.</a:t>
+                      </a:r>
+                      <a:endParaRPr lang="en-US" sz="1400" b="0" i="0" u="none" strike="noStrike">
+                        <a:solidFill>
+                          <a:srgbClr val="000000"/>
+                        </a:solidFill>
+                        <a:effectLst/>
+                        <a:latin typeface="Aptos" panose="020B0004020202020204" pitchFamily="34" charset="0"/>
+                      </a:endParaRPr>
+                    </a:p>
+                  </a:txBody>
+                  <a:tcPr marL="6633" marR="6633" marT="6633" marB="0" anchor="ctr"/>
+                </a:tc>
+                <a:tc>
+                  <a:txBody>
+                    <a:bodyPr/>
+                    <a:lstStyle/>
+                    <a:p>
+                      <a:pPr algn="r" rtl="0" fontAlgn="ctr">
+                        <a:buNone/>
+                      </a:pPr>
+                      <a:r>
+                        <a:rPr lang="en-US" sz="1400" u="none" strike="noStrike">
+                          <a:effectLst/>
+                        </a:rPr>
+                        <a:t>20000015</a:t>
+                      </a:r>
+                      <a:endParaRPr lang="en-US" sz="1400" b="0" i="0" u="none" strike="noStrike">
+                        <a:solidFill>
+                          <a:srgbClr val="000000"/>
+                        </a:solidFill>
+                        <a:effectLst/>
+                        <a:latin typeface="Aptos" panose="020B0004020202020204" pitchFamily="34" charset="0"/>
+                      </a:endParaRPr>
+                    </a:p>
+                  </a:txBody>
+                  <a:tcPr marL="6633" marR="6633" marT="6633" marB="0" anchor="ctr"/>
+                </a:tc>
+                <a:extLst>
+                  <a:ext uri="{0D108BD9-81ED-4DB2-BD59-A6C34878D82A}">
+                    <a16:rowId xmlns:a16="http://schemas.microsoft.com/office/drawing/2014/main" val="2615809111"/>
+                  </a:ext>
+                </a:extLst>
+              </a:tr>
+              <a:tr h="580677">
+                <a:tc>
+                  <a:txBody>
+                    <a:bodyPr/>
+                    <a:lstStyle/>
+                    <a:p>
+                      <a:pPr algn="l" rtl="0" fontAlgn="ctr">
+                        <a:buNone/>
+                      </a:pPr>
+                      <a:r>
+                        <a:rPr lang="en-US" sz="1400" u="none" strike="noStrike">
+                          <a:effectLst/>
+                        </a:rPr>
+                        <a:t>data_arc</a:t>
+                      </a:r>
+                      <a:endParaRPr lang="en-US" sz="1400" b="0" i="0" u="none" strike="noStrike">
+                        <a:solidFill>
+                          <a:srgbClr val="000000"/>
+                        </a:solidFill>
+                        <a:effectLst/>
+                        <a:latin typeface="Aptos" panose="020B0004020202020204" pitchFamily="34" charset="0"/>
+                      </a:endParaRPr>
+                    </a:p>
+                  </a:txBody>
+                  <a:tcPr marL="6633" marR="6633" marT="6633" marB="0" anchor="ctr"/>
+                </a:tc>
+                <a:tc>
+                  <a:txBody>
+                    <a:bodyPr/>
+                    <a:lstStyle/>
+                    <a:p>
+                      <a:pPr algn="ctr" rtl="0" fontAlgn="ctr">
+                        <a:buNone/>
+                      </a:pPr>
+                      <a:r>
+                        <a:rPr lang="en-US" sz="1400" u="none" strike="noStrike">
+                          <a:effectLst/>
+                        </a:rPr>
+                        <a:t>number</a:t>
+                      </a:r>
+                      <a:endParaRPr lang="en-US" sz="1400" b="0" i="0" u="none" strike="noStrike">
+                        <a:solidFill>
+                          <a:srgbClr val="000000"/>
+                        </a:solidFill>
+                        <a:effectLst/>
+                        <a:latin typeface="Aptos" panose="020B0004020202020204" pitchFamily="34" charset="0"/>
+                      </a:endParaRPr>
+                    </a:p>
+                  </a:txBody>
+                  <a:tcPr marL="6633" marR="6633" marT="6633" marB="0" anchor="ctr"/>
+                </a:tc>
+                <a:tc>
+                  <a:txBody>
+                    <a:bodyPr/>
+                    <a:lstStyle/>
+                    <a:p>
+                      <a:pPr algn="l" rtl="0" fontAlgn="ctr">
+                        <a:buNone/>
+                      </a:pPr>
+                      <a:r>
+                        <a:rPr lang="en-US" sz="1400" u="none" strike="noStrike">
+                          <a:effectLst/>
+                        </a:rPr>
+                        <a:t>number of days spanned by the observations used in the orbit determination</a:t>
+                      </a:r>
+                      <a:endParaRPr lang="en-US" sz="1400" b="0" i="0" u="none" strike="noStrike">
+                        <a:solidFill>
+                          <a:srgbClr val="000000"/>
+                        </a:solidFill>
+                        <a:effectLst/>
+                        <a:latin typeface="Aptos" panose="020B0004020202020204" pitchFamily="34" charset="0"/>
+                      </a:endParaRPr>
+                    </a:p>
+                  </a:txBody>
+                  <a:tcPr marL="6633" marR="6633" marT="6633" marB="0" anchor="ctr"/>
+                </a:tc>
+                <a:tc>
+                  <a:txBody>
+                    <a:bodyPr/>
+                    <a:lstStyle/>
+                    <a:p>
+                      <a:pPr algn="l" rtl="0" fontAlgn="ctr">
+                        <a:buNone/>
+                      </a:pPr>
+                      <a:r>
+                        <a:rPr lang="en-US" sz="1400" u="none" strike="noStrike">
+                          <a:effectLst/>
+                        </a:rPr>
+                        <a:t>How long have we been observing the orbit of the object, to use real data for modeling the predicted orbit?</a:t>
+                      </a:r>
+                      <a:endParaRPr lang="en-US" sz="1400" b="0" i="0" u="none" strike="noStrike">
+                        <a:solidFill>
+                          <a:srgbClr val="000000"/>
+                        </a:solidFill>
+                        <a:effectLst/>
+                        <a:latin typeface="Aptos" panose="020B0004020202020204" pitchFamily="34" charset="0"/>
+                      </a:endParaRPr>
+                    </a:p>
+                  </a:txBody>
+                  <a:tcPr marL="6633" marR="6633" marT="6633" marB="0" anchor="ctr"/>
+                </a:tc>
+                <a:tc>
+                  <a:txBody>
+                    <a:bodyPr/>
+                    <a:lstStyle/>
+                    <a:p>
+                      <a:pPr algn="r" rtl="0" fontAlgn="ctr">
+                        <a:buNone/>
+                      </a:pPr>
+                      <a:r>
+                        <a:rPr lang="en-US" sz="1400" u="none" strike="noStrike">
+                          <a:effectLst/>
+                        </a:rPr>
+                        <a:t>80789</a:t>
+                      </a:r>
+                      <a:endParaRPr lang="en-US" sz="1400" b="0" i="0" u="none" strike="noStrike">
+                        <a:solidFill>
+                          <a:srgbClr val="000000"/>
+                        </a:solidFill>
+                        <a:effectLst/>
+                        <a:latin typeface="Aptos" panose="020B0004020202020204" pitchFamily="34" charset="0"/>
+                      </a:endParaRPr>
+                    </a:p>
+                  </a:txBody>
+                  <a:tcPr marL="6633" marR="6633" marT="6633" marB="0" anchor="ctr"/>
+                </a:tc>
+                <a:extLst>
+                  <a:ext uri="{0D108BD9-81ED-4DB2-BD59-A6C34878D82A}">
+                    <a16:rowId xmlns:a16="http://schemas.microsoft.com/office/drawing/2014/main" val="428326155"/>
+                  </a:ext>
+                </a:extLst>
+              </a:tr>
+              <a:tr h="580677">
+                <a:tc>
+                  <a:txBody>
+                    <a:bodyPr/>
+                    <a:lstStyle/>
+                    <a:p>
+                      <a:pPr algn="l" rtl="0" fontAlgn="ctr">
+                        <a:buNone/>
+                      </a:pPr>
+                      <a:r>
+                        <a:rPr lang="en-US" sz="1400" u="none" strike="noStrike">
+                          <a:effectLst/>
+                        </a:rPr>
+                        <a:t>n_obs_used</a:t>
+                      </a:r>
+                      <a:endParaRPr lang="en-US" sz="1400" b="0" i="0" u="none" strike="noStrike">
+                        <a:solidFill>
+                          <a:srgbClr val="000000"/>
+                        </a:solidFill>
+                        <a:effectLst/>
+                        <a:latin typeface="Aptos" panose="020B0004020202020204" pitchFamily="34" charset="0"/>
+                      </a:endParaRPr>
+                    </a:p>
+                  </a:txBody>
+                  <a:tcPr marL="6633" marR="6633" marT="6633" marB="0" anchor="ctr"/>
+                </a:tc>
+                <a:tc>
+                  <a:txBody>
+                    <a:bodyPr/>
+                    <a:lstStyle/>
+                    <a:p>
+                      <a:pPr algn="ctr" rtl="0" fontAlgn="ctr">
+                        <a:buNone/>
+                      </a:pPr>
+                      <a:r>
+                        <a:rPr lang="en-US" sz="1400" u="none" strike="noStrike">
+                          <a:effectLst/>
+                        </a:rPr>
+                        <a:t>number</a:t>
+                      </a:r>
+                      <a:endParaRPr lang="en-US" sz="1400" b="0" i="0" u="none" strike="noStrike">
+                        <a:solidFill>
+                          <a:srgbClr val="000000"/>
+                        </a:solidFill>
+                        <a:effectLst/>
+                        <a:latin typeface="Aptos" panose="020B0004020202020204" pitchFamily="34" charset="0"/>
+                      </a:endParaRPr>
+                    </a:p>
+                  </a:txBody>
+                  <a:tcPr marL="6633" marR="6633" marT="6633" marB="0" anchor="ctr"/>
+                </a:tc>
+                <a:tc>
+                  <a:txBody>
+                    <a:bodyPr/>
+                    <a:lstStyle/>
+                    <a:p>
+                      <a:pPr algn="l" rtl="0" fontAlgn="ctr">
+                        <a:buNone/>
+                      </a:pPr>
+                      <a:r>
+                        <a:rPr lang="en-US" sz="1400" u="none" strike="noStrike">
+                          <a:effectLst/>
+                        </a:rPr>
+                        <a:t>total number of observations of all types used in the orbit</a:t>
+                      </a:r>
+                      <a:endParaRPr lang="en-US" sz="1400" b="0" i="0" u="none" strike="noStrike">
+                        <a:solidFill>
+                          <a:srgbClr val="000000"/>
+                        </a:solidFill>
+                        <a:effectLst/>
+                        <a:latin typeface="Aptos" panose="020B0004020202020204" pitchFamily="34" charset="0"/>
+                      </a:endParaRPr>
+                    </a:p>
+                  </a:txBody>
+                  <a:tcPr marL="6633" marR="6633" marT="6633" marB="0" anchor="ctr"/>
+                </a:tc>
+                <a:tc>
+                  <a:txBody>
+                    <a:bodyPr/>
+                    <a:lstStyle/>
+                    <a:p>
+                      <a:pPr algn="l" rtl="0" fontAlgn="ctr">
+                        <a:buNone/>
+                      </a:pPr>
+                      <a:r>
+                        <a:rPr lang="en-US" sz="1400" u="none" strike="noStrike" dirty="0">
+                          <a:effectLst/>
+                        </a:rPr>
+                        <a:t>How many times has the orbit been observed, the number of samples we have to use in the model?</a:t>
+                      </a:r>
+                      <a:endParaRPr lang="en-US" sz="1400" b="0" i="0" u="none" strike="noStrike" dirty="0">
+                        <a:solidFill>
+                          <a:srgbClr val="000000"/>
+                        </a:solidFill>
+                        <a:effectLst/>
+                        <a:latin typeface="Aptos" panose="020B0004020202020204" pitchFamily="34" charset="0"/>
+                      </a:endParaRPr>
+                    </a:p>
+                  </a:txBody>
+                  <a:tcPr marL="6633" marR="6633" marT="6633" marB="0" anchor="ctr"/>
+                </a:tc>
+                <a:tc>
+                  <a:txBody>
+                    <a:bodyPr/>
+                    <a:lstStyle/>
+                    <a:p>
+                      <a:pPr algn="r" rtl="0" fontAlgn="ctr">
+                        <a:buNone/>
+                      </a:pPr>
+                      <a:r>
+                        <a:rPr lang="en-US" sz="1400" u="none" strike="noStrike" dirty="0">
+                          <a:effectLst/>
+                        </a:rPr>
+                        <a:t>9764</a:t>
+                      </a:r>
+                      <a:endParaRPr lang="en-US" sz="1400" b="0" i="0" u="none" strike="noStrike" dirty="0">
+                        <a:solidFill>
+                          <a:srgbClr val="000000"/>
+                        </a:solidFill>
+                        <a:effectLst/>
+                        <a:latin typeface="Aptos" panose="020B0004020202020204" pitchFamily="34" charset="0"/>
+                      </a:endParaRPr>
+                    </a:p>
+                  </a:txBody>
+                  <a:tcPr marL="6633" marR="6633" marT="6633" marB="0" anchor="ctr"/>
+                </a:tc>
+                <a:extLst>
+                  <a:ext uri="{0D108BD9-81ED-4DB2-BD59-A6C34878D82A}">
+                    <a16:rowId xmlns:a16="http://schemas.microsoft.com/office/drawing/2014/main" val="662443640"/>
+                  </a:ext>
+                </a:extLst>
+              </a:tr>
+            </a:tbl>
+          </a:graphicData>
+        </a:graphic>
+      </p:graphicFrame>
+    </p:spTree>
+    <p:extLst>
+      <p:ext uri="{BB962C8B-B14F-4D97-AF65-F5344CB8AC3E}">
+        <p14:creationId xmlns:p14="http://schemas.microsoft.com/office/powerpoint/2010/main" val="3969572359"/>
+      </p:ext>
+    </p:extLst>
+  </p:cSld>
+  <p:clrMapOvr>
+    <a:masterClrMapping/>
+  </p:clrMapOvr>
+</p:sld>
+</file>
+
+<file path=ppt/slides/slide9.xml><?xml version="1.0" encoding="utf-8"?>
+<p:sld xmlns:a="http://schemas.openxmlformats.org/drawingml/2006/main" xmlns:r="http://schemas.openxmlformats.org/officeDocument/2006/relationships" xmlns:p="http://schemas.openxmlformats.org/presentationml/2006/main">
+  <p:cSld>
+    <p:spTree>
+      <p:nvGrpSpPr>
+        <p:cNvPr id="1" name=""/>
+        <p:cNvGrpSpPr/>
+        <p:nvPr/>
+      </p:nvGrpSpPr>
+      <p:grpSpPr>
+        <a:xfrm>
+          <a:off x="0" y="0"/>
+          <a:ext cx="0" cy="0"/>
+          <a:chOff x="0" y="0"/>
+          <a:chExt cx="0" cy="0"/>
+        </a:xfrm>
+      </p:grpSpPr>
+      <p:pic>
+        <p:nvPicPr>
+          <p:cNvPr id="29" name="Picture 28">
+            <a:extLst>
+              <a:ext uri="{FF2B5EF4-FFF2-40B4-BE49-F238E27FC236}">
+                <a16:creationId xmlns:a16="http://schemas.microsoft.com/office/drawing/2014/main" id="{B1C0618A-1B77-4801-E567-C25CB8D298B1}"/>
+              </a:ext>
+            </a:extLst>
+          </p:cNvPr>
+          <p:cNvPicPr>
+            <a:picLocks noChangeAspect="1"/>
+          </p:cNvPicPr>
+          <p:nvPr/>
+        </p:nvPicPr>
+        <p:blipFill>
+          <a:blip r:embed="rId2">
+            <a:alphaModFix amt="50000"/>
+          </a:blip>
+          <a:stretch>
+            <a:fillRect/>
+          </a:stretch>
+        </p:blipFill>
+        <p:spPr>
+          <a:xfrm>
+            <a:off x="5451707" y="203215"/>
+            <a:ext cx="5706271" cy="4124901"/>
+          </a:xfrm>
+          <a:prstGeom prst="rect">
+            <a:avLst/>
+          </a:prstGeom>
+        </p:spPr>
+      </p:pic>
+      <p:sp>
+        <p:nvSpPr>
+          <p:cNvPr id="2" name="Title 1">
+            <a:extLst>
+              <a:ext uri="{FF2B5EF4-FFF2-40B4-BE49-F238E27FC236}">
+                <a16:creationId xmlns:a16="http://schemas.microsoft.com/office/drawing/2014/main" id="{1FF9FA11-CBBB-8BAE-496B-9C906E1E55F9}"/>
+              </a:ext>
+            </a:extLst>
+          </p:cNvPr>
+          <p:cNvSpPr>
+            <a:spLocks noGrp="1"/>
+          </p:cNvSpPr>
+          <p:nvPr>
+            <p:ph type="title"/>
+          </p:nvPr>
+        </p:nvSpPr>
+        <p:spPr/>
+        <p:txBody>
+          <a:bodyPr/>
+          <a:lstStyle/>
+          <a:p>
+            <a:r>
+              <a:rPr lang="en-US" dirty="0"/>
+              <a:t>Tidy Data</a:t>
+            </a:r>
+          </a:p>
+        </p:txBody>
+      </p:sp>
+      <p:sp>
+        <p:nvSpPr>
+          <p:cNvPr id="3" name="Content Placeholder 2">
+            <a:extLst>
+              <a:ext uri="{FF2B5EF4-FFF2-40B4-BE49-F238E27FC236}">
+                <a16:creationId xmlns:a16="http://schemas.microsoft.com/office/drawing/2014/main" id="{CA8C3866-043F-4D6F-C891-C6B119E9C19C}"/>
+              </a:ext>
+            </a:extLst>
+          </p:cNvPr>
+          <p:cNvSpPr>
+            <a:spLocks noGrp="1"/>
+          </p:cNvSpPr>
+          <p:nvPr>
+            <p:ph idx="1"/>
+          </p:nvPr>
+        </p:nvSpPr>
+        <p:spPr>
+          <a:xfrm>
+            <a:off x="838200" y="1488877"/>
+            <a:ext cx="3546231" cy="1322262"/>
+          </a:xfrm>
+        </p:spPr>
+        <p:txBody>
+          <a:bodyPr>
+            <a:normAutofit/>
+          </a:bodyPr>
+          <a:lstStyle/>
+          <a:p>
+            <a:pPr marL="0" indent="0">
+              <a:buNone/>
+            </a:pPr>
+            <a:r>
+              <a:rPr lang="en-US" sz="2000" dirty="0"/>
+              <a:t>Each variable is a column</a:t>
+            </a:r>
+          </a:p>
+          <a:p>
+            <a:pPr marL="0" indent="0">
+              <a:buNone/>
+            </a:pPr>
+            <a:r>
+              <a:rPr lang="en-US" sz="2000" dirty="0"/>
+              <a:t>Each observation is a row</a:t>
+            </a:r>
+          </a:p>
+          <a:p>
+            <a:pPr marL="0" indent="0">
+              <a:buNone/>
+            </a:pPr>
+            <a:r>
+              <a:rPr lang="en-US" sz="2000" dirty="0"/>
+              <a:t>Each cell is a single value</a:t>
+            </a:r>
+          </a:p>
+        </p:txBody>
+      </p:sp>
+      <p:cxnSp>
+        <p:nvCxnSpPr>
+          <p:cNvPr id="8" name="Connector: Elbow 7">
+            <a:extLst>
+              <a:ext uri="{FF2B5EF4-FFF2-40B4-BE49-F238E27FC236}">
+                <a16:creationId xmlns:a16="http://schemas.microsoft.com/office/drawing/2014/main" id="{4951EA53-80EE-9C14-FE55-C155691781BD}"/>
+              </a:ext>
+            </a:extLst>
+          </p:cNvPr>
+          <p:cNvCxnSpPr>
+            <a:cxnSpLocks/>
+          </p:cNvCxnSpPr>
+          <p:nvPr/>
+        </p:nvCxnSpPr>
+        <p:spPr>
+          <a:xfrm flipV="1">
+            <a:off x="4774103" y="3428999"/>
+            <a:ext cx="1610522" cy="909514"/>
+          </a:xfrm>
+          <a:prstGeom prst="bentConnector3">
+            <a:avLst>
+              <a:gd name="adj1" fmla="val 50000"/>
+            </a:avLst>
+          </a:prstGeom>
+          <a:ln>
+            <a:tailEnd type="triangle"/>
+          </a:ln>
+        </p:spPr>
+        <p:style>
+          <a:lnRef idx="2">
+            <a:schemeClr val="accent1"/>
+          </a:lnRef>
+          <a:fillRef idx="0">
+            <a:schemeClr val="accent1"/>
+          </a:fillRef>
+          <a:effectRef idx="1">
+            <a:schemeClr val="accent1"/>
+          </a:effectRef>
+          <a:fontRef idx="minor">
+            <a:schemeClr val="tx1"/>
+          </a:fontRef>
+        </p:style>
+      </p:cxnSp>
+      <p:sp>
+        <p:nvSpPr>
+          <p:cNvPr id="19" name="TextBox 18">
+            <a:extLst>
+              <a:ext uri="{FF2B5EF4-FFF2-40B4-BE49-F238E27FC236}">
+                <a16:creationId xmlns:a16="http://schemas.microsoft.com/office/drawing/2014/main" id="{D6ECCDFC-3A87-F96D-82C8-7EFC2A90A596}"/>
+              </a:ext>
+            </a:extLst>
+          </p:cNvPr>
+          <p:cNvSpPr txBox="1"/>
+          <p:nvPr/>
+        </p:nvSpPr>
+        <p:spPr>
+          <a:xfrm>
+            <a:off x="2183423" y="5865886"/>
+            <a:ext cx="855784" cy="369332"/>
+          </a:xfrm>
+          <a:prstGeom prst="rect">
+            <a:avLst/>
+          </a:prstGeom>
+          <a:noFill/>
+        </p:spPr>
+        <p:txBody>
+          <a:bodyPr wrap="square" rtlCol="0">
+            <a:spAutoFit/>
+          </a:bodyPr>
+          <a:lstStyle/>
+          <a:p>
+            <a:r>
+              <a:rPr lang="en-US" dirty="0"/>
+              <a:t>before</a:t>
+            </a:r>
+          </a:p>
+        </p:txBody>
+      </p:sp>
+      <p:sp>
+        <p:nvSpPr>
+          <p:cNvPr id="20" name="TextBox 19">
+            <a:extLst>
+              <a:ext uri="{FF2B5EF4-FFF2-40B4-BE49-F238E27FC236}">
+                <a16:creationId xmlns:a16="http://schemas.microsoft.com/office/drawing/2014/main" id="{98819929-AAF4-BC4C-6CC4-569D10CB2AC1}"/>
+              </a:ext>
+            </a:extLst>
+          </p:cNvPr>
+          <p:cNvSpPr txBox="1"/>
+          <p:nvPr/>
+        </p:nvSpPr>
+        <p:spPr>
+          <a:xfrm>
+            <a:off x="8352605" y="6488668"/>
+            <a:ext cx="855784" cy="369332"/>
+          </a:xfrm>
+          <a:prstGeom prst="rect">
+            <a:avLst/>
+          </a:prstGeom>
+          <a:noFill/>
+        </p:spPr>
+        <p:txBody>
+          <a:bodyPr wrap="square" rtlCol="0">
+            <a:spAutoFit/>
+          </a:bodyPr>
+          <a:lstStyle/>
+          <a:p>
+            <a:r>
+              <a:rPr lang="en-US" dirty="0"/>
+              <a:t>after</a:t>
+            </a:r>
+          </a:p>
+        </p:txBody>
+      </p:sp>
+      <p:pic>
+        <p:nvPicPr>
+          <p:cNvPr id="24" name="Picture 23">
+            <a:extLst>
+              <a:ext uri="{FF2B5EF4-FFF2-40B4-BE49-F238E27FC236}">
+                <a16:creationId xmlns:a16="http://schemas.microsoft.com/office/drawing/2014/main" id="{70189096-8418-1D9D-9F61-DC2D0AE07021}"/>
+              </a:ext>
+            </a:extLst>
+          </p:cNvPr>
+          <p:cNvPicPr>
+            <a:picLocks noChangeAspect="1"/>
+          </p:cNvPicPr>
+          <p:nvPr/>
+        </p:nvPicPr>
+        <p:blipFill>
+          <a:blip r:embed="rId3"/>
+          <a:stretch>
+            <a:fillRect/>
+          </a:stretch>
+        </p:blipFill>
+        <p:spPr>
+          <a:xfrm>
+            <a:off x="6384625" y="342469"/>
+            <a:ext cx="4791744" cy="6173061"/>
+          </a:xfrm>
+          <a:prstGeom prst="rect">
+            <a:avLst/>
+          </a:prstGeom>
+          <a:ln>
+            <a:solidFill>
+              <a:schemeClr val="tx1"/>
+            </a:solidFill>
+          </a:ln>
+        </p:spPr>
+      </p:pic>
+      <p:pic>
+        <p:nvPicPr>
+          <p:cNvPr id="27" name="Picture 26">
+            <a:extLst>
+              <a:ext uri="{FF2B5EF4-FFF2-40B4-BE49-F238E27FC236}">
+                <a16:creationId xmlns:a16="http://schemas.microsoft.com/office/drawing/2014/main" id="{24359187-AF12-403A-C9EC-66995FCC209F}"/>
+              </a:ext>
+            </a:extLst>
+          </p:cNvPr>
+          <p:cNvPicPr>
+            <a:picLocks noChangeAspect="1"/>
+          </p:cNvPicPr>
+          <p:nvPr/>
+        </p:nvPicPr>
+        <p:blipFill>
+          <a:blip r:embed="rId4"/>
+          <a:stretch>
+            <a:fillRect/>
+          </a:stretch>
+        </p:blipFill>
+        <p:spPr>
+          <a:xfrm>
+            <a:off x="838200" y="2790346"/>
+            <a:ext cx="4121225" cy="3075540"/>
           </a:xfrm>
           <a:prstGeom prst="rect">
             <a:avLst/>
@@ -4158,7 +6292,7 @@
     </p:spTree>
     <p:extLst>
       <p:ext uri="{BB962C8B-B14F-4D97-AF65-F5344CB8AC3E}">
-        <p14:creationId xmlns:p14="http://schemas.microsoft.com/office/powerpoint/2010/main" val="2682637863"/>
+        <p14:creationId xmlns:p14="http://schemas.microsoft.com/office/powerpoint/2010/main" val="4269069606"/>
       </p:ext>
     </p:extLst>
   </p:cSld>

</xml_diff>